<commit_message>
feat: package hybrid deployment release candidate
</commit_message>
<xml_diff>
--- a/presentation/MARKOUT-UHI10.pptx
+++ b/presentation/MARKOUT-UHI10.pptx
@@ -2,21 +2,21 @@
 <file path=ppt/presentation.xml><?xml version="1.0" encoding="utf-8"?>
 <p:presentation xmlns:p="http://schemas.openxmlformats.org/presentationml/2006/main">
   <p:sldMasterIdLst>
-    <p:sldMasterId xmlns:r="http://schemas.openxmlformats.org/officeDocument/2006/relationships" id="2147483648" r:id="R358e6679807d49eb"/>
+    <p:sldMasterId xmlns:r="http://schemas.openxmlformats.org/officeDocument/2006/relationships" id="2147483648" r:id="Rd7fbfe864c8b4a59"/>
   </p:sldMasterIdLst>
   <p:notesMasterIdLst>
-    <p:notesMasterId xmlns:r="http://schemas.openxmlformats.org/officeDocument/2006/relationships" r:id="R04298cd6b8f74435"/>
+    <p:notesMasterId xmlns:r="http://schemas.openxmlformats.org/officeDocument/2006/relationships" r:id="R1501d757e5574688"/>
   </p:notesMasterIdLst>
   <p:sldIdLst>
-    <p:sldId xmlns:r="http://schemas.openxmlformats.org/officeDocument/2006/relationships" id="256" r:id="R1a5dd9ad8767466b"/>
-    <p:sldId xmlns:r="http://schemas.openxmlformats.org/officeDocument/2006/relationships" id="257" r:id="R9646cd1689a24c85"/>
-    <p:sldId xmlns:r="http://schemas.openxmlformats.org/officeDocument/2006/relationships" id="258" r:id="R1b2c24b8402c4df6"/>
-    <p:sldId xmlns:r="http://schemas.openxmlformats.org/officeDocument/2006/relationships" id="259" r:id="Rbe22332c54e1457d"/>
-    <p:sldId xmlns:r="http://schemas.openxmlformats.org/officeDocument/2006/relationships" id="260" r:id="R7a72f9e2b55d4920"/>
-    <p:sldId xmlns:r="http://schemas.openxmlformats.org/officeDocument/2006/relationships" id="261" r:id="R9f9911c305e14ed8"/>
-    <p:sldId xmlns:r="http://schemas.openxmlformats.org/officeDocument/2006/relationships" id="262" r:id="R63905894fb6b4026"/>
-    <p:sldId xmlns:r="http://schemas.openxmlformats.org/officeDocument/2006/relationships" id="263" r:id="R604b86b51e954417"/>
-    <p:sldId xmlns:r="http://schemas.openxmlformats.org/officeDocument/2006/relationships" id="264" r:id="R337649d0e9af48d3"/>
+    <p:sldId xmlns:r="http://schemas.openxmlformats.org/officeDocument/2006/relationships" id="256" r:id="R4a96ce31ccb44d60"/>
+    <p:sldId xmlns:r="http://schemas.openxmlformats.org/officeDocument/2006/relationships" id="257" r:id="R4731a7b6652b47f3"/>
+    <p:sldId xmlns:r="http://schemas.openxmlformats.org/officeDocument/2006/relationships" id="258" r:id="Rcb33d3006756486d"/>
+    <p:sldId xmlns:r="http://schemas.openxmlformats.org/officeDocument/2006/relationships" id="259" r:id="Rcceaf3d34fd541f9"/>
+    <p:sldId xmlns:r="http://schemas.openxmlformats.org/officeDocument/2006/relationships" id="260" r:id="R7b5abfc421eb47af"/>
+    <p:sldId xmlns:r="http://schemas.openxmlformats.org/officeDocument/2006/relationships" id="261" r:id="R03670309ce154302"/>
+    <p:sldId xmlns:r="http://schemas.openxmlformats.org/officeDocument/2006/relationships" id="262" r:id="Ra7fc08a4c1e24cb9"/>
+    <p:sldId xmlns:r="http://schemas.openxmlformats.org/officeDocument/2006/relationships" id="263" r:id="R4039986728c145c2"/>
+    <p:sldId xmlns:r="http://schemas.openxmlformats.org/officeDocument/2006/relationships" id="264" r:id="R61374a8b808643de"/>
   </p:sldIdLst>
   <p:sldSz cx="12192000" cy="6858000"/>
   <p:notesSz cx="6858000" cy="9144000"/>
@@ -455,7 +455,7 @@
           </a:p>
           <a:p xmlns:a="http://schemas.openxmlformats.org/drawingml/2006/main">
             <a:r>
-              <a:t>Position Reactive Network as core settlement infrastructure, not an alerting add-on.</a:t>
+              <a:t>Frame Reactive as a lightweight optional accelerator; Circle is the primary authenticated settlement route.</a:t>
             </a:r>
           </a:p>
           <a:p xmlns:a="http://schemas.openxmlformats.org/drawingml/2006/main">
@@ -471,6 +471,11 @@
           <a:p xmlns:a="http://schemas.openxmlformats.org/drawingml/2006/main">
             <a:r>
               <a:t>- web/public/og.png</a:t>
+            </a:r>
+          </a:p>
+          <a:p xmlns:a="http://schemas.openxmlformats.org/drawingml/2006/main">
+            <a:r>
+              <a:t>- docs/HYBRID_SETTLEMENT.md</a:t>
             </a:r>
           </a:p>
           <a:p xmlns:a="http://schemas.openxmlformats.org/drawingml/2006/main">
@@ -645,7 +650,7 @@
           <a:lstStyle xmlns:a="http://schemas.openxmlformats.org/drawingml/2006/main"/>
           <a:p xmlns:a="http://schemas.openxmlformats.org/drawingml/2006/main">
             <a:r>
-              <a:t>Walk left to right and stop on settlement: the callback never chooses arbitrary values; the hook applies the frozen curve.</a:t>
+              <a:t>Walk left to right: the publisher verifies Pyth, and the hook still applies the frozen curve after authenticated delivery.</a:t>
             </a:r>
           </a:p>
           <a:p xmlns:a="http://schemas.openxmlformats.org/drawingml/2006/main">
@@ -675,7 +680,7 @@
           </a:p>
           <a:p xmlns:a="http://schemas.openxmlformats.org/drawingml/2006/main">
             <a:r>
-              <a:t>- docs/REACTIVE_LIFECYCLE.md</a:t>
+              <a:t>- docs/HYBRID_SETTLEMENT.md</a:t>
             </a:r>
           </a:p>
           <a:p xmlns:a="http://schemas.openxmlformats.org/drawingml/2006/main">
@@ -1065,12 +1070,17 @@
           <a:lstStyle xmlns:a="http://schemas.openxmlformats.org/drawingml/2006/main"/>
           <a:p xmlns:a="http://schemas.openxmlformats.org/drawingml/2006/main">
             <a:r>
-              <a:t>Reactive observes both request and reference events, advances a bounded cron cursor, and retries terminal callbacks until acknowledgement.</a:t>
-            </a:r>
-          </a:p>
-          <a:p xmlns:a="http://schemas.openxmlformats.org/drawingml/2006/main">
-            <a:r>
-              <a:t>The destination adapter authenticates both callback transport and Reactive identity; replays become no-ops after terminal state.</a:t>
+              <a:t>Circle carries the Pyth-verified observation as the primary authenticated message path.</a:t>
+            </a:r>
+          </a:p>
+          <a:p xmlns:a="http://schemas.openxmlformats.org/drawingml/2006/main">
+            <a:r>
+              <a:t>The stateless Reactive pulse can mirror the same event, while the coordinator makes duplicate delivery harmless.</a:t>
+            </a:r>
+          </a:p>
+          <a:p xmlns:a="http://schemas.openxmlformats.org/drawingml/2006/main">
+            <a:r>
+              <a:t>The hook retains custody, maturity checks, economic validation, settlement, and permissionless expiry.</a:t>
             </a:r>
           </a:p>
           <a:p xmlns:a="http://schemas.openxmlformats.org/drawingml/2006/main">
@@ -1085,12 +1095,22 @@
           </a:p>
           <a:p xmlns:a="http://schemas.openxmlformats.org/drawingml/2006/main">
             <a:r>
-              <a:t>- docs/REACTIVE_LIFECYCLE.md</a:t>
+              <a:t>- docs/HYBRID_SETTLEMENT.md</a:t>
             </a:r>
           </a:p>
           <a:p xmlns:a="http://schemas.openxmlformats.org/drawingml/2006/main">
             <a:r>
               <a:t>- docs/THREAT_MODEL.md</a:t>
+            </a:r>
+          </a:p>
+          <a:p xmlns:a="http://schemas.openxmlformats.org/drawingml/2006/main">
+            <a:r>
+              <a:t>- docs/PHASE_12_VERIFICATION.md</a:t>
+            </a:r>
+          </a:p>
+          <a:p xmlns:a="http://schemas.openxmlformats.org/drawingml/2006/main">
+            <a:r>
+              <a:t>- docs/PHASE_13_VERIFICATION.md</a:t>
             </a:r>
           </a:p>
           <a:p xmlns:a="http://schemas.openxmlformats.org/drawingml/2006/main">
@@ -1165,7 +1185,7 @@
           <a:lstStyle xmlns:a="http://schemas.openxmlformats.org/drawingml/2006/main"/>
           <a:p xmlns:a="http://schemas.openxmlformats.org/drawingml/2006/main">
             <a:r>
-              <a:t>The cumulative gate includes adversarial authorization, reentrancy, expiry, oracle failure, replay, and insolvency cases.</a:t>
+              <a:t>The cumulative gate includes adversarial authorization, reentrancy, expiry, oracle failure, replay, transport races, and insolvency cases.</a:t>
             </a:r>
           </a:p>
           <a:p xmlns:a="http://schemas.openxmlformats.org/drawingml/2006/main">
@@ -1186,6 +1206,21 @@
           <a:p xmlns:a="http://schemas.openxmlformats.org/drawingml/2006/main">
             <a:r>
               <a:t>- docs/PHASE_7_VERIFICATION.md</a:t>
+            </a:r>
+          </a:p>
+          <a:p xmlns:a="http://schemas.openxmlformats.org/drawingml/2006/main">
+            <a:r>
+              <a:t>- docs/PHASE_11_VERIFICATION.md</a:t>
+            </a:r>
+          </a:p>
+          <a:p xmlns:a="http://schemas.openxmlformats.org/drawingml/2006/main">
+            <a:r>
+              <a:t>- docs/PHASE_12_VERIFICATION.md</a:t>
+            </a:r>
+          </a:p>
+          <a:p xmlns:a="http://schemas.openxmlformats.org/drawingml/2006/main">
+            <a:r>
+              <a:t>- docs/PHASE_13_VERIFICATION.md</a:t>
             </a:r>
           </a:p>
           <a:p xmlns:a="http://schemas.openxmlformats.org/drawingml/2006/main">
@@ -1275,7 +1310,12 @@
           </a:p>
           <a:p xmlns:a="http://schemas.openxmlformats.org/drawingml/2006/main">
             <a:r>
-              <a:t>For the final presentation, follow this slide with the two public explorer traces once lREACT funding exists.</a:t>
+              <a:t>Finish on the real Circle publication, attestation relay, settlement, and rebate claim once those transactions exist.</a:t>
+            </a:r>
+          </a:p>
+          <a:p xmlns:a="http://schemas.openxmlformats.org/drawingml/2006/main">
+            <a:r>
+              <a:t>Show Reactive separately only when a public destination callback exists.</a:t>
             </a:r>
           </a:p>
           <a:p xmlns:a="http://schemas.openxmlformats.org/drawingml/2006/main">
@@ -1295,7 +1335,7 @@
           </a:p>
           <a:p xmlns:a="http://schemas.openxmlformats.org/drawingml/2006/main">
             <a:r>
-              <a:t>- docs/PHASE_8_VERIFICATION.md</a:t>
+              <a:t>- docs/HYBRID_TESTNET_DEPLOYMENT.md</a:t>
             </a:r>
           </a:p>
           <a:p xmlns:a="http://schemas.openxmlformats.org/drawingml/2006/main">
@@ -1368,7 +1408,7 @@
   </p:cSld>
   <p:clrMap bg1="lt1" tx1="dk1" bg2="lt2" tx2="dk2" accent1="accent1" accent2="accent2" accent3="accent3" accent4="accent4" accent5="accent5" accent6="accent6" hlink="hlink" folHlink="folHlink"/>
   <p:sldLayoutIdLst>
-    <p:sldLayoutId xmlns:r="http://schemas.openxmlformats.org/officeDocument/2006/relationships" id="2147483649" r:id="R0aba258d741e4758"/>
+    <p:sldLayoutId xmlns:r="http://schemas.openxmlformats.org/officeDocument/2006/relationships" id="2147483649" r:id="Rf5788590262047b7"/>
   </p:sldLayoutIdLst>
   <p:txStyles>
     <p:titleStyle>
@@ -1923,7 +1963,7 @@
           <p:nvPr/>
         </p:nvPicPr>
         <p:blipFill>
-          <a:blip xmlns:r="http://schemas.openxmlformats.org/officeDocument/2006/relationships" xmlns:a="http://schemas.openxmlformats.org/drawingml/2006/main" r:embed="R734a517ba2564e08"/>
+          <a:blip xmlns:r="http://schemas.openxmlformats.org/officeDocument/2006/relationships" xmlns:a="http://schemas.openxmlformats.org/drawingml/2006/main" r:embed="R6d663a9986524bf9"/>
           <a:stretch xmlns:a="http://schemas.openxmlformats.org/drawingml/2006/main"/>
         </p:blipFill>
         <p:spPr>
@@ -1998,6 +2038,7 @@
           <a:lstStyle xmlns:a="http://schemas.openxmlformats.org/drawingml/2006/main"/>
           <a:p xmlns:a="http://schemas.openxmlformats.org/drawingml/2006/main">
             <a:pPr>
+              <a:buNone/>
               <a:defRPr sz="1050" b="1">
                 <a:solidFill>
                   <a:srgbClr val="8AFFAD"/>
@@ -2048,6 +2089,7 @@
           <a:lstStyle xmlns:a="http://schemas.openxmlformats.org/drawingml/2006/main"/>
           <a:p xmlns:a="http://schemas.openxmlformats.org/drawingml/2006/main">
             <a:pPr algn="r">
+              <a:buNone/>
               <a:defRPr sz="900">
                 <a:solidFill>
                   <a:srgbClr val="9CA9B5"/>
@@ -2129,6 +2171,7 @@
           <a:lstStyle xmlns:a="http://schemas.openxmlformats.org/drawingml/2006/main"/>
           <a:p xmlns:a="http://schemas.openxmlformats.org/drawingml/2006/main">
             <a:pPr>
+              <a:buNone/>
               <a:defRPr sz="2850" b="1">
                 <a:solidFill>
                   <a:srgbClr val="F4F1E8"/>
@@ -2179,6 +2222,7 @@
           <a:lstStyle xmlns:a="http://schemas.openxmlformats.org/drawingml/2006/main"/>
           <a:p xmlns:a="http://schemas.openxmlformats.org/drawingml/2006/main">
             <a:pPr>
+              <a:buNone/>
               <a:defRPr sz="1275" b="1">
                 <a:solidFill>
                   <a:srgbClr val="F59E0B"/>
@@ -2229,6 +2273,7 @@
           <a:lstStyle xmlns:a="http://schemas.openxmlformats.org/drawingml/2006/main"/>
           <a:p xmlns:a="http://schemas.openxmlformats.org/drawingml/2006/main">
             <a:pPr>
+              <a:buNone/>
               <a:defRPr sz="2700" b="1">
                 <a:solidFill>
                   <a:srgbClr val="F4F1E8"/>
@@ -2279,6 +2324,7 @@
           <a:lstStyle xmlns:a="http://schemas.openxmlformats.org/drawingml/2006/main"/>
           <a:p xmlns:a="http://schemas.openxmlformats.org/drawingml/2006/main">
             <a:pPr>
+              <a:buNone/>
               <a:defRPr sz="1575">
                 <a:solidFill>
                   <a:srgbClr val="9CA9B5"/>
@@ -2329,6 +2375,7 @@
           <a:lstStyle xmlns:a="http://schemas.openxmlformats.org/drawingml/2006/main"/>
           <a:p xmlns:a="http://schemas.openxmlformats.org/drawingml/2006/main">
             <a:pPr algn="ctr">
+              <a:buNone/>
               <a:defRPr sz="4800" b="1">
                 <a:solidFill>
                   <a:srgbClr val="34414B"/>
@@ -2379,6 +2426,7 @@
           <a:lstStyle xmlns:a="http://schemas.openxmlformats.org/drawingml/2006/main"/>
           <a:p xmlns:a="http://schemas.openxmlformats.org/drawingml/2006/main">
             <a:pPr>
+              <a:buNone/>
               <a:defRPr sz="1275" b="1">
                 <a:solidFill>
                   <a:srgbClr val="8AFFAD"/>
@@ -2429,6 +2477,7 @@
           <a:lstStyle xmlns:a="http://schemas.openxmlformats.org/drawingml/2006/main"/>
           <a:p xmlns:a="http://schemas.openxmlformats.org/drawingml/2006/main">
             <a:pPr>
+              <a:buNone/>
               <a:defRPr sz="2700" b="1">
                 <a:solidFill>
                   <a:srgbClr val="F4F1E8"/>
@@ -2479,6 +2528,7 @@
           <a:lstStyle xmlns:a="http://schemas.openxmlformats.org/drawingml/2006/main"/>
           <a:p xmlns:a="http://schemas.openxmlformats.org/drawingml/2006/main">
             <a:pPr>
+              <a:buNone/>
               <a:defRPr sz="1575">
                 <a:solidFill>
                   <a:srgbClr val="9CA9B5"/>
@@ -2560,6 +2610,7 @@
           <a:lstStyle xmlns:a="http://schemas.openxmlformats.org/drawingml/2006/main"/>
           <a:p xmlns:a="http://schemas.openxmlformats.org/drawingml/2006/main">
             <a:pPr>
+              <a:buNone/>
               <a:defRPr sz="2100" b="1">
                 <a:solidFill>
                   <a:srgbClr val="8AFFAD"/>
@@ -2639,6 +2690,7 @@
           <a:lstStyle xmlns:a="http://schemas.openxmlformats.org/drawingml/2006/main"/>
           <a:p xmlns:a="http://schemas.openxmlformats.org/drawingml/2006/main">
             <a:pPr>
+              <a:buNone/>
               <a:defRPr sz="1050" b="1">
                 <a:solidFill>
                   <a:srgbClr val="8AFFAD"/>
@@ -2689,6 +2741,7 @@
           <a:lstStyle xmlns:a="http://schemas.openxmlformats.org/drawingml/2006/main"/>
           <a:p xmlns:a="http://schemas.openxmlformats.org/drawingml/2006/main">
             <a:pPr algn="r">
+              <a:buNone/>
               <a:defRPr sz="900">
                 <a:solidFill>
                   <a:srgbClr val="9CA9B5"/>
@@ -2770,6 +2823,7 @@
           <a:lstStyle xmlns:a="http://schemas.openxmlformats.org/drawingml/2006/main"/>
           <a:p xmlns:a="http://schemas.openxmlformats.org/drawingml/2006/main">
             <a:pPr>
+              <a:buNone/>
               <a:defRPr sz="2850" b="1">
                 <a:solidFill>
                   <a:srgbClr val="F4F1E8"/>
@@ -2820,6 +2874,7 @@
           <a:lstStyle xmlns:a="http://schemas.openxmlformats.org/drawingml/2006/main"/>
           <a:p xmlns:a="http://schemas.openxmlformats.org/drawingml/2006/main">
             <a:pPr>
+              <a:buNone/>
               <a:defRPr sz="1575">
                 <a:solidFill>
                   <a:srgbClr val="9CA9B5"/>
@@ -2905,6 +2960,7 @@
           <a:lstStyle xmlns:a="http://schemas.openxmlformats.org/drawingml/2006/main"/>
           <a:p xmlns:a="http://schemas.openxmlformats.org/drawingml/2006/main">
             <a:pPr>
+              <a:buNone/>
               <a:defRPr sz="1275" b="1">
                 <a:solidFill>
                   <a:srgbClr val="8AFFAD"/>
@@ -2955,6 +3011,7 @@
           <a:lstStyle xmlns:a="http://schemas.openxmlformats.org/drawingml/2006/main"/>
           <a:p xmlns:a="http://schemas.openxmlformats.org/drawingml/2006/main">
             <a:pPr>
+              <a:buNone/>
               <a:defRPr sz="1425" b="1">
                 <a:solidFill>
                   <a:srgbClr val="F4F1E8"/>
@@ -3005,6 +3062,7 @@
           <a:lstStyle xmlns:a="http://schemas.openxmlformats.org/drawingml/2006/main"/>
           <a:p xmlns:a="http://schemas.openxmlformats.org/drawingml/2006/main">
             <a:pPr>
+              <a:buNone/>
               <a:defRPr sz="1200">
                 <a:solidFill>
                   <a:srgbClr val="9CA9B5"/>
@@ -3022,6 +3080,7 @@
           </a:p>
           <a:p xmlns:a="http://schemas.openxmlformats.org/drawingml/2006/main">
             <a:pPr>
+              <a:buNone/>
               <a:defRPr sz="1200">
                 <a:solidFill>
                   <a:srgbClr val="9CA9B5"/>
@@ -3107,6 +3166,7 @@
           <a:lstStyle xmlns:a="http://schemas.openxmlformats.org/drawingml/2006/main"/>
           <a:p xmlns:a="http://schemas.openxmlformats.org/drawingml/2006/main">
             <a:pPr>
+              <a:buNone/>
               <a:defRPr sz="1275" b="1">
                 <a:solidFill>
                   <a:srgbClr val="8AFFAD"/>
@@ -3157,6 +3217,7 @@
           <a:lstStyle xmlns:a="http://schemas.openxmlformats.org/drawingml/2006/main"/>
           <a:p xmlns:a="http://schemas.openxmlformats.org/drawingml/2006/main">
             <a:pPr>
+              <a:buNone/>
               <a:defRPr sz="1425" b="1">
                 <a:solidFill>
                   <a:srgbClr val="F4F1E8"/>
@@ -3207,6 +3268,7 @@
           <a:lstStyle xmlns:a="http://schemas.openxmlformats.org/drawingml/2006/main"/>
           <a:p xmlns:a="http://schemas.openxmlformats.org/drawingml/2006/main">
             <a:pPr>
+              <a:buNone/>
               <a:defRPr sz="1200">
                 <a:solidFill>
                   <a:srgbClr val="9CA9B5"/>
@@ -3224,6 +3286,7 @@
           </a:p>
           <a:p xmlns:a="http://schemas.openxmlformats.org/drawingml/2006/main">
             <a:pPr>
+              <a:buNone/>
               <a:defRPr sz="1200">
                 <a:solidFill>
                   <a:srgbClr val="9CA9B5"/>
@@ -3309,6 +3372,7 @@
           <a:lstStyle xmlns:a="http://schemas.openxmlformats.org/drawingml/2006/main"/>
           <a:p xmlns:a="http://schemas.openxmlformats.org/drawingml/2006/main">
             <a:pPr>
+              <a:buNone/>
               <a:defRPr sz="1275" b="1">
                 <a:solidFill>
                   <a:srgbClr val="8AFFAD"/>
@@ -3359,6 +3423,7 @@
           <a:lstStyle xmlns:a="http://schemas.openxmlformats.org/drawingml/2006/main"/>
           <a:p xmlns:a="http://schemas.openxmlformats.org/drawingml/2006/main">
             <a:pPr>
+              <a:buNone/>
               <a:defRPr sz="1425" b="1">
                 <a:solidFill>
                   <a:srgbClr val="F4F1E8"/>
@@ -3409,6 +3474,7 @@
           <a:lstStyle xmlns:a="http://schemas.openxmlformats.org/drawingml/2006/main"/>
           <a:p xmlns:a="http://schemas.openxmlformats.org/drawingml/2006/main">
             <a:pPr>
+              <a:buNone/>
               <a:defRPr sz="1200">
                 <a:solidFill>
                   <a:srgbClr val="9CA9B5"/>
@@ -3421,11 +3487,12 @@
                   <a:srgbClr val="9CA9B5"/>
                 </a:solidFill>
               </a:rPr>
-              <a:t>three-market</a:t>
+              <a:t>Pyth-verified</a:t>
             </a:r>
           </a:p>
           <a:p xmlns:a="http://schemas.openxmlformats.org/drawingml/2006/main">
             <a:pPr>
+              <a:buNone/>
               <a:defRPr sz="1200">
                 <a:solidFill>
                   <a:srgbClr val="9CA9B5"/>
@@ -3438,7 +3505,7 @@
                   <a:srgbClr val="9CA9B5"/>
                 </a:solidFill>
               </a:rPr>
-              <a:t>median sample</a:t>
+              <a:t>price observation</a:t>
             </a:r>
           </a:p>
         </p:txBody>
@@ -3511,6 +3578,7 @@
           <a:lstStyle xmlns:a="http://schemas.openxmlformats.org/drawingml/2006/main"/>
           <a:p xmlns:a="http://schemas.openxmlformats.org/drawingml/2006/main">
             <a:pPr>
+              <a:buNone/>
               <a:defRPr sz="1275" b="1">
                 <a:solidFill>
                   <a:srgbClr val="8AFFAD"/>
@@ -3561,6 +3629,7 @@
           <a:lstStyle xmlns:a="http://schemas.openxmlformats.org/drawingml/2006/main"/>
           <a:p xmlns:a="http://schemas.openxmlformats.org/drawingml/2006/main">
             <a:pPr>
+              <a:buNone/>
               <a:defRPr sz="1425" b="1">
                 <a:solidFill>
                   <a:srgbClr val="F4F1E8"/>
@@ -3611,6 +3680,7 @@
           <a:lstStyle xmlns:a="http://schemas.openxmlformats.org/drawingml/2006/main"/>
           <a:p xmlns:a="http://schemas.openxmlformats.org/drawingml/2006/main">
             <a:pPr>
+              <a:buNone/>
               <a:defRPr sz="1200">
                 <a:solidFill>
                   <a:srgbClr val="9CA9B5"/>
@@ -3628,6 +3698,7 @@
           </a:p>
           <a:p xmlns:a="http://schemas.openxmlformats.org/drawingml/2006/main">
             <a:pPr>
+              <a:buNone/>
               <a:defRPr sz="1200">
                 <a:solidFill>
                   <a:srgbClr val="9CA9B5"/>
@@ -3713,6 +3784,7 @@
           <a:lstStyle xmlns:a="http://schemas.openxmlformats.org/drawingml/2006/main"/>
           <a:p xmlns:a="http://schemas.openxmlformats.org/drawingml/2006/main">
             <a:pPr>
+              <a:buNone/>
               <a:defRPr sz="1275" b="1">
                 <a:solidFill>
                   <a:srgbClr val="8AFFAD"/>
@@ -3763,6 +3835,7 @@
           <a:lstStyle xmlns:a="http://schemas.openxmlformats.org/drawingml/2006/main"/>
           <a:p xmlns:a="http://schemas.openxmlformats.org/drawingml/2006/main">
             <a:pPr>
+              <a:buNone/>
               <a:defRPr sz="1425" b="1">
                 <a:solidFill>
                   <a:srgbClr val="F4F1E8"/>
@@ -3813,6 +3886,7 @@
           <a:lstStyle xmlns:a="http://schemas.openxmlformats.org/drawingml/2006/main"/>
           <a:p xmlns:a="http://schemas.openxmlformats.org/drawingml/2006/main">
             <a:pPr>
+              <a:buNone/>
               <a:defRPr sz="1200">
                 <a:solidFill>
                   <a:srgbClr val="9CA9B5"/>
@@ -3830,6 +3904,7 @@
           </a:p>
           <a:p xmlns:a="http://schemas.openxmlformats.org/drawingml/2006/main">
             <a:pPr>
+              <a:buNone/>
               <a:defRPr sz="1200">
                 <a:solidFill>
                   <a:srgbClr val="9CA9B5"/>
@@ -3849,7 +3924,7 @@
       </p:sp>
       <p:cxnSp>
         <p:nvCxnSpPr>
-          <p:cNvPr id="56" name=""/>
+          <p:cNvPr id="114" name=""/>
           <p:cNvCxnSpPr>
             <a:stCxn xmlns:a="http://schemas.openxmlformats.org/drawingml/2006/main" id="6" idx="3"/>
             <a:endCxn xmlns:a="http://schemas.openxmlformats.org/drawingml/2006/main" id="10" idx="1"/>
@@ -3875,7 +3950,7 @@
       </p:cxnSp>
       <p:cxnSp>
         <p:nvCxnSpPr>
-          <p:cNvPr id="57" name=""/>
+          <p:cNvPr id="115" name=""/>
           <p:cNvCxnSpPr>
             <a:stCxn xmlns:a="http://schemas.openxmlformats.org/drawingml/2006/main" id="10" idx="3"/>
             <a:endCxn xmlns:a="http://schemas.openxmlformats.org/drawingml/2006/main" id="14" idx="1"/>
@@ -3901,7 +3976,7 @@
       </p:cxnSp>
       <p:cxnSp>
         <p:nvCxnSpPr>
-          <p:cNvPr id="58" name=""/>
+          <p:cNvPr id="116" name=""/>
           <p:cNvCxnSpPr>
             <a:stCxn xmlns:a="http://schemas.openxmlformats.org/drawingml/2006/main" id="14" idx="3"/>
             <a:endCxn xmlns:a="http://schemas.openxmlformats.org/drawingml/2006/main" id="18" idx="1"/>
@@ -3927,7 +4002,7 @@
       </p:cxnSp>
       <p:cxnSp>
         <p:nvCxnSpPr>
-          <p:cNvPr id="59" name=""/>
+          <p:cNvPr id="117" name=""/>
           <p:cNvCxnSpPr>
             <a:stCxn xmlns:a="http://schemas.openxmlformats.org/drawingml/2006/main" id="18" idx="3"/>
             <a:endCxn xmlns:a="http://schemas.openxmlformats.org/drawingml/2006/main" id="22" idx="1"/>
@@ -3984,6 +4059,7 @@
           <a:lstStyle xmlns:a="http://schemas.openxmlformats.org/drawingml/2006/main"/>
           <a:p xmlns:a="http://schemas.openxmlformats.org/drawingml/2006/main">
             <a:pPr algn="ctr">
+              <a:buNone/>
               <a:defRPr sz="1650" b="1">
                 <a:solidFill>
                   <a:srgbClr val="8AFFAD"/>
@@ -4063,6 +4139,7 @@
           <a:lstStyle xmlns:a="http://schemas.openxmlformats.org/drawingml/2006/main"/>
           <a:p xmlns:a="http://schemas.openxmlformats.org/drawingml/2006/main">
             <a:pPr>
+              <a:buNone/>
               <a:defRPr sz="1050" b="1">
                 <a:solidFill>
                   <a:srgbClr val="8AFFAD"/>
@@ -4113,6 +4190,7 @@
           <a:lstStyle xmlns:a="http://schemas.openxmlformats.org/drawingml/2006/main"/>
           <a:p xmlns:a="http://schemas.openxmlformats.org/drawingml/2006/main">
             <a:pPr algn="r">
+              <a:buNone/>
               <a:defRPr sz="900">
                 <a:solidFill>
                   <a:srgbClr val="9CA9B5"/>
@@ -4194,6 +4272,7 @@
           <a:lstStyle xmlns:a="http://schemas.openxmlformats.org/drawingml/2006/main"/>
           <a:p xmlns:a="http://schemas.openxmlformats.org/drawingml/2006/main">
             <a:pPr>
+              <a:buNone/>
               <a:defRPr sz="2850" b="1">
                 <a:solidFill>
                   <a:srgbClr val="F4F1E8"/>
@@ -4213,14 +4292,14 @@
       </p:sp>
       <p:pic>
         <p:nvPicPr>
-          <p:cNvPr id="11" name=""/>
+          <p:cNvPr id="13" name=""/>
           <p:cNvPicPr>
             <a:picLocks xmlns:a="http://schemas.openxmlformats.org/drawingml/2006/main" noChangeAspect="1"/>
           </p:cNvPicPr>
           <p:nvPr/>
         </p:nvPicPr>
         <p:blipFill>
-          <a:blip xmlns:r="http://schemas.openxmlformats.org/officeDocument/2006/relationships" xmlns:a="http://schemas.openxmlformats.org/drawingml/2006/main" r:embed="Rcc4f5b2922994973"/>
+          <a:blip xmlns:r="http://schemas.openxmlformats.org/officeDocument/2006/relationships" xmlns:a="http://schemas.openxmlformats.org/drawingml/2006/main" r:embed="R0da935d81a404ec8"/>
           <a:stretch xmlns:a="http://schemas.openxmlformats.org/drawingml/2006/main"/>
         </p:blipFill>
         <p:spPr>
@@ -4266,6 +4345,7 @@
           <a:lstStyle xmlns:a="http://schemas.openxmlformats.org/drawingml/2006/main"/>
           <a:p xmlns:a="http://schemas.openxmlformats.org/drawingml/2006/main">
             <a:pPr algn="ctr">
+              <a:buNone/>
               <a:defRPr sz="1575" b="1">
                 <a:solidFill>
                   <a:srgbClr val="8AFFAD"/>
@@ -4345,6 +4425,7 @@
           <a:lstStyle xmlns:a="http://schemas.openxmlformats.org/drawingml/2006/main"/>
           <a:p xmlns:a="http://schemas.openxmlformats.org/drawingml/2006/main">
             <a:pPr>
+              <a:buNone/>
               <a:defRPr sz="1050" b="1">
                 <a:solidFill>
                   <a:srgbClr val="8AFFAD"/>
@@ -4395,6 +4476,7 @@
           <a:lstStyle xmlns:a="http://schemas.openxmlformats.org/drawingml/2006/main"/>
           <a:p xmlns:a="http://schemas.openxmlformats.org/drawingml/2006/main">
             <a:pPr algn="r">
+              <a:buNone/>
               <a:defRPr sz="900">
                 <a:solidFill>
                   <a:srgbClr val="9CA9B5"/>
@@ -4476,6 +4558,7 @@
           <a:lstStyle xmlns:a="http://schemas.openxmlformats.org/drawingml/2006/main"/>
           <a:p xmlns:a="http://schemas.openxmlformats.org/drawingml/2006/main">
             <a:pPr>
+              <a:buNone/>
               <a:defRPr sz="2850" b="1">
                 <a:solidFill>
                   <a:srgbClr val="F4F1E8"/>
@@ -4495,14 +4578,14 @@
       </p:sp>
       <p:pic>
         <p:nvPicPr>
-          <p:cNvPr id="14" name=""/>
+          <p:cNvPr id="16" name=""/>
           <p:cNvPicPr>
             <a:picLocks xmlns:a="http://schemas.openxmlformats.org/drawingml/2006/main" noChangeAspect="1"/>
           </p:cNvPicPr>
           <p:nvPr/>
         </p:nvPicPr>
         <p:blipFill>
-          <a:blip xmlns:r="http://schemas.openxmlformats.org/officeDocument/2006/relationships" xmlns:a="http://schemas.openxmlformats.org/drawingml/2006/main" r:embed="Ra64b862b3d81422f"/>
+          <a:blip xmlns:r="http://schemas.openxmlformats.org/officeDocument/2006/relationships" xmlns:a="http://schemas.openxmlformats.org/drawingml/2006/main" r:embed="Re6e1980a233246d9"/>
           <a:stretch xmlns:a="http://schemas.openxmlformats.org/drawingml/2006/main"/>
         </p:blipFill>
         <p:spPr>
@@ -4548,6 +4631,7 @@
           <a:lstStyle xmlns:a="http://schemas.openxmlformats.org/drawingml/2006/main"/>
           <a:p xmlns:a="http://schemas.openxmlformats.org/drawingml/2006/main">
             <a:pPr>
+              <a:buNone/>
               <a:defRPr sz="3150" b="1">
                 <a:solidFill>
                   <a:srgbClr val="8AFFAD"/>
@@ -4598,6 +4682,7 @@
           <a:lstStyle xmlns:a="http://schemas.openxmlformats.org/drawingml/2006/main"/>
           <a:p xmlns:a="http://schemas.openxmlformats.org/drawingml/2006/main">
             <a:pPr>
+              <a:buNone/>
               <a:defRPr sz="1275">
                 <a:solidFill>
                   <a:srgbClr val="9CA9B5"/>
@@ -4615,6 +4700,7 @@
           </a:p>
           <a:p xmlns:a="http://schemas.openxmlformats.org/drawingml/2006/main">
             <a:pPr>
+              <a:buNone/>
               <a:defRPr sz="1275">
                 <a:solidFill>
                   <a:srgbClr val="9CA9B5"/>
@@ -4665,6 +4751,7 @@
           <a:lstStyle xmlns:a="http://schemas.openxmlformats.org/drawingml/2006/main"/>
           <a:p xmlns:a="http://schemas.openxmlformats.org/drawingml/2006/main">
             <a:pPr>
+              <a:buNone/>
               <a:defRPr sz="3150" b="1">
                 <a:solidFill>
                   <a:srgbClr val="F59E0B"/>
@@ -4715,6 +4802,7 @@
           <a:lstStyle xmlns:a="http://schemas.openxmlformats.org/drawingml/2006/main"/>
           <a:p xmlns:a="http://schemas.openxmlformats.org/drawingml/2006/main">
             <a:pPr>
+              <a:buNone/>
               <a:defRPr sz="1275">
                 <a:solidFill>
                   <a:srgbClr val="9CA9B5"/>
@@ -4732,6 +4820,7 @@
           </a:p>
           <a:p xmlns:a="http://schemas.openxmlformats.org/drawingml/2006/main">
             <a:pPr>
+              <a:buNone/>
               <a:defRPr sz="1275">
                 <a:solidFill>
                   <a:srgbClr val="9CA9B5"/>
@@ -4811,6 +4900,7 @@
           <a:lstStyle xmlns:a="http://schemas.openxmlformats.org/drawingml/2006/main"/>
           <a:p xmlns:a="http://schemas.openxmlformats.org/drawingml/2006/main">
             <a:pPr>
+              <a:buNone/>
               <a:defRPr sz="1050" b="1">
                 <a:solidFill>
                   <a:srgbClr val="8AFFAD"/>
@@ -4861,6 +4951,7 @@
           <a:lstStyle xmlns:a="http://schemas.openxmlformats.org/drawingml/2006/main"/>
           <a:p xmlns:a="http://schemas.openxmlformats.org/drawingml/2006/main">
             <a:pPr algn="r">
+              <a:buNone/>
               <a:defRPr sz="900">
                 <a:solidFill>
                   <a:srgbClr val="9CA9B5"/>
@@ -4942,6 +5033,7 @@
           <a:lstStyle xmlns:a="http://schemas.openxmlformats.org/drawingml/2006/main"/>
           <a:p xmlns:a="http://schemas.openxmlformats.org/drawingml/2006/main">
             <a:pPr>
+              <a:buNone/>
               <a:defRPr sz="2850" b="1">
                 <a:solidFill>
                   <a:srgbClr val="F4F1E8"/>
@@ -4961,14 +5053,14 @@
       </p:sp>
       <p:pic>
         <p:nvPicPr>
-          <p:cNvPr id="16" name=""/>
+          <p:cNvPr id="18" name=""/>
           <p:cNvPicPr>
             <a:picLocks xmlns:a="http://schemas.openxmlformats.org/drawingml/2006/main" noChangeAspect="1"/>
           </p:cNvPicPr>
           <p:nvPr/>
         </p:nvPicPr>
         <p:blipFill>
-          <a:blip xmlns:r="http://schemas.openxmlformats.org/officeDocument/2006/relationships" xmlns:a="http://schemas.openxmlformats.org/drawingml/2006/main" r:embed="Ra11e10393d184250"/>
+          <a:blip xmlns:r="http://schemas.openxmlformats.org/officeDocument/2006/relationships" xmlns:a="http://schemas.openxmlformats.org/drawingml/2006/main" r:embed="R5e3b56b4f5294cc7"/>
           <a:stretch xmlns:a="http://schemas.openxmlformats.org/drawingml/2006/main"/>
         </p:blipFill>
         <p:spPr>
@@ -5014,6 +5106,7 @@
           <a:lstStyle xmlns:a="http://schemas.openxmlformats.org/drawingml/2006/main"/>
           <a:p xmlns:a="http://schemas.openxmlformats.org/drawingml/2006/main">
             <a:pPr>
+              <a:buNone/>
               <a:defRPr sz="3600" b="1">
                 <a:solidFill>
                   <a:srgbClr val="41D47A"/>
@@ -5064,6 +5157,7 @@
           <a:lstStyle xmlns:a="http://schemas.openxmlformats.org/drawingml/2006/main"/>
           <a:p xmlns:a="http://schemas.openxmlformats.org/drawingml/2006/main">
             <a:pPr>
+              <a:buNone/>
               <a:defRPr sz="1275">
                 <a:solidFill>
                   <a:srgbClr val="9CA9B5"/>
@@ -5114,6 +5208,7 @@
           <a:lstStyle xmlns:a="http://schemas.openxmlformats.org/drawingml/2006/main"/>
           <a:p xmlns:a="http://schemas.openxmlformats.org/drawingml/2006/main">
             <a:pPr>
+              <a:buNone/>
               <a:defRPr sz="3600" b="1">
                 <a:solidFill>
                   <a:srgbClr val="EC4899"/>
@@ -5164,6 +5259,7 @@
           <a:lstStyle xmlns:a="http://schemas.openxmlformats.org/drawingml/2006/main"/>
           <a:p xmlns:a="http://schemas.openxmlformats.org/drawingml/2006/main">
             <a:pPr>
+              <a:buNone/>
               <a:defRPr sz="1275">
                 <a:solidFill>
                   <a:srgbClr val="9CA9B5"/>
@@ -5214,6 +5310,7 @@
           <a:lstStyle xmlns:a="http://schemas.openxmlformats.org/drawingml/2006/main"/>
           <a:p xmlns:a="http://schemas.openxmlformats.org/drawingml/2006/main">
             <a:pPr>
+              <a:buNone/>
               <a:defRPr sz="3600" b="1">
                 <a:solidFill>
                   <a:srgbClr val="F4F1E8"/>
@@ -5264,6 +5361,7 @@
           <a:lstStyle xmlns:a="http://schemas.openxmlformats.org/drawingml/2006/main"/>
           <a:p xmlns:a="http://schemas.openxmlformats.org/drawingml/2006/main">
             <a:pPr>
+              <a:buNone/>
               <a:defRPr sz="1275">
                 <a:solidFill>
                   <a:srgbClr val="9CA9B5"/>
@@ -5281,6 +5379,7 @@
           </a:p>
           <a:p xmlns:a="http://schemas.openxmlformats.org/drawingml/2006/main">
             <a:pPr>
+              <a:buNone/>
               <a:defRPr sz="1275">
                 <a:solidFill>
                   <a:srgbClr val="9CA9B5"/>
@@ -5360,6 +5459,7 @@
           <a:lstStyle xmlns:a="http://schemas.openxmlformats.org/drawingml/2006/main"/>
           <a:p xmlns:a="http://schemas.openxmlformats.org/drawingml/2006/main">
             <a:pPr>
+              <a:buNone/>
               <a:defRPr sz="1050" b="1">
                 <a:solidFill>
                   <a:srgbClr val="8AFFAD"/>
@@ -5410,6 +5510,7 @@
           <a:lstStyle xmlns:a="http://schemas.openxmlformats.org/drawingml/2006/main"/>
           <a:p xmlns:a="http://schemas.openxmlformats.org/drawingml/2006/main">
             <a:pPr algn="r">
+              <a:buNone/>
               <a:defRPr sz="900">
                 <a:solidFill>
                   <a:srgbClr val="9CA9B5"/>
@@ -5491,6 +5592,7 @@
           <a:lstStyle xmlns:a="http://schemas.openxmlformats.org/drawingml/2006/main"/>
           <a:p xmlns:a="http://schemas.openxmlformats.org/drawingml/2006/main">
             <a:pPr>
+              <a:buNone/>
               <a:defRPr sz="2850" b="1">
                 <a:solidFill>
                   <a:srgbClr val="F4F1E8"/>
@@ -5503,7 +5605,7 @@
                   <a:srgbClr val="F4F1E8"/>
                 </a:solidFill>
               </a:rPr>
-              <a:t>Reactive Network makes delayed settlement autonomous.</a:t>
+              <a:t>Two transport paths; one immutable settlement boundary.</a:t>
             </a:r>
           </a:p>
         </p:txBody>
@@ -5541,6 +5643,7 @@
           <a:lstStyle xmlns:a="http://schemas.openxmlformats.org/drawingml/2006/main"/>
           <a:p xmlns:a="http://schemas.openxmlformats.org/drawingml/2006/main">
             <a:pPr>
+              <a:buNone/>
               <a:defRPr sz="1575">
                 <a:solidFill>
                   <a:srgbClr val="9CA9B5"/>
@@ -5553,7 +5656,7 @@
                   <a:srgbClr val="9CA9B5"/>
                 </a:solidFill>
               </a:rPr>
-              <a:t>It owns timing and delivery. The hook alone owns custody and final accounting.</a:t>
+              <a:t>Circle is primary. Reactive is optional. The hook alone owns custody and final accounting.</a:t>
             </a:r>
           </a:p>
         </p:txBody>
@@ -5665,7 +5768,7 @@
       </p:sp>
       <p:cxnSp>
         <p:nvCxnSpPr>
-          <p:cNvPr id="26" name=""/>
+          <p:cNvPr id="46" name=""/>
           <p:cNvCxnSpPr>
             <a:stCxn xmlns:a="http://schemas.openxmlformats.org/drawingml/2006/main" id="6" idx="3"/>
             <a:endCxn xmlns:a="http://schemas.openxmlformats.org/drawingml/2006/main" id="7" idx="1"/>
@@ -5691,7 +5794,7 @@
       </p:cxnSp>
       <p:cxnSp>
         <p:nvCxnSpPr>
-          <p:cNvPr id="27" name=""/>
+          <p:cNvPr id="47" name=""/>
           <p:cNvCxnSpPr>
             <a:stCxn xmlns:a="http://schemas.openxmlformats.org/drawingml/2006/main" id="7" idx="3"/>
             <a:endCxn xmlns:a="http://schemas.openxmlformats.org/drawingml/2006/main" id="8" idx="1"/>
@@ -5748,6 +5851,7 @@
           <a:lstStyle xmlns:a="http://schemas.openxmlformats.org/drawingml/2006/main"/>
           <a:p xmlns:a="http://schemas.openxmlformats.org/drawingml/2006/main">
             <a:pPr>
+              <a:buNone/>
               <a:defRPr sz="1725" b="1">
                 <a:solidFill>
                   <a:srgbClr val="F4F1E8"/>
@@ -5798,6 +5902,7 @@
           <a:lstStyle xmlns:a="http://schemas.openxmlformats.org/drawingml/2006/main"/>
           <a:p xmlns:a="http://schemas.openxmlformats.org/drawingml/2006/main">
             <a:pPr>
+              <a:buNone/>
               <a:defRPr sz="1425">
                 <a:solidFill>
                   <a:srgbClr val="9CA9B5"/>
@@ -5815,6 +5920,7 @@
           </a:p>
           <a:p xmlns:a="http://schemas.openxmlformats.org/drawingml/2006/main">
             <a:pPr>
+              <a:buNone/>
               <a:defRPr sz="1425">
                 <a:solidFill>
                   <a:srgbClr val="9CA9B5"/>
@@ -5832,6 +5938,7 @@
           </a:p>
           <a:p xmlns:a="http://schemas.openxmlformats.org/drawingml/2006/main">
             <a:pPr>
+              <a:buNone/>
               <a:defRPr sz="1425">
                 <a:solidFill>
                   <a:srgbClr val="9CA9B5"/>
@@ -5882,6 +5989,7 @@
           <a:lstStyle xmlns:a="http://schemas.openxmlformats.org/drawingml/2006/main"/>
           <a:p xmlns:a="http://schemas.openxmlformats.org/drawingml/2006/main">
             <a:pPr>
+              <a:buNone/>
               <a:defRPr sz="1725" b="1">
                 <a:solidFill>
                   <a:srgbClr val="8AFFAD"/>
@@ -5894,7 +6002,7 @@
                   <a:srgbClr val="8AFFAD"/>
                 </a:solidFill>
               </a:rPr>
-              <a:t>REACTIVE</a:t>
+              <a:t>TRANSPORTS</a:t>
             </a:r>
           </a:p>
         </p:txBody>
@@ -5932,6 +6040,7 @@
           <a:lstStyle xmlns:a="http://schemas.openxmlformats.org/drawingml/2006/main"/>
           <a:p xmlns:a="http://schemas.openxmlformats.org/drawingml/2006/main">
             <a:pPr>
+              <a:buNone/>
               <a:defRPr sz="1425">
                 <a:solidFill>
                   <a:srgbClr val="9CA9B5"/>
@@ -5944,11 +6053,12 @@
                   <a:srgbClr val="9CA9B5"/>
                 </a:solidFill>
               </a:rPr>
-              <a:t>Subscribe to events</a:t>
+              <a:t>Pyth verifies price</a:t>
             </a:r>
           </a:p>
           <a:p xmlns:a="http://schemas.openxmlformats.org/drawingml/2006/main">
             <a:pPr>
+              <a:buNone/>
               <a:defRPr sz="1425">
                 <a:solidFill>
                   <a:srgbClr val="9CA9B5"/>
@@ -5961,11 +6071,12 @@
                   <a:srgbClr val="9CA9B5"/>
                 </a:solidFill>
               </a:rPr>
-              <a:t>Wait five minutes</a:t>
+              <a:t>Circle carries primary</a:t>
             </a:r>
           </a:p>
           <a:p xmlns:a="http://schemas.openxmlformats.org/drawingml/2006/main">
             <a:pPr>
+              <a:buNone/>
               <a:defRPr sz="1425">
                 <a:solidFill>
                   <a:srgbClr val="9CA9B5"/>
@@ -5978,7 +6089,7 @@
                   <a:srgbClr val="9CA9B5"/>
                 </a:solidFill>
               </a:rPr>
-              <a:t>Request sample + retry</a:t>
+              <a:t>Reactive mirrors event</a:t>
             </a:r>
           </a:p>
         </p:txBody>
@@ -6016,6 +6127,7 @@
           <a:lstStyle xmlns:a="http://schemas.openxmlformats.org/drawingml/2006/main"/>
           <a:p xmlns:a="http://schemas.openxmlformats.org/drawingml/2006/main">
             <a:pPr>
+              <a:buNone/>
               <a:defRPr sz="1725" b="1">
                 <a:solidFill>
                   <a:srgbClr val="F4F1E8"/>
@@ -6028,7 +6140,7 @@
                   <a:srgbClr val="F4F1E8"/>
                 </a:solidFill>
               </a:rPr>
-              <a:t>AUTHENTICATED</a:t>
+              <a:t>COORDINATOR</a:t>
             </a:r>
           </a:p>
         </p:txBody>
@@ -6066,6 +6178,7 @@
           <a:lstStyle xmlns:a="http://schemas.openxmlformats.org/drawingml/2006/main"/>
           <a:p xmlns:a="http://schemas.openxmlformats.org/drawingml/2006/main">
             <a:pPr>
+              <a:buNone/>
               <a:defRPr sz="1425">
                 <a:solidFill>
                   <a:srgbClr val="9CA9B5"/>
@@ -6078,11 +6191,12 @@
                   <a:srgbClr val="9CA9B5"/>
                 </a:solidFill>
               </a:rPr>
-              <a:t>Proxy + identity checks</a:t>
+              <a:t>Authenticate sources</a:t>
             </a:r>
           </a:p>
           <a:p xmlns:a="http://schemas.openxmlformats.org/drawingml/2006/main">
             <a:pPr>
+              <a:buNone/>
               <a:defRPr sz="1425">
                 <a:solidFill>
                   <a:srgbClr val="9CA9B5"/>
@@ -6095,11 +6209,12 @@
                   <a:srgbClr val="9CA9B5"/>
                 </a:solidFill>
               </a:rPr>
-              <a:t>Settle once or expire</a:t>
+              <a:t>First valid delivery wins</a:t>
             </a:r>
           </a:p>
           <a:p xmlns:a="http://schemas.openxmlformats.org/drawingml/2006/main">
             <a:pPr>
+              <a:buNone/>
               <a:defRPr sz="1425">
                 <a:solidFill>
                   <a:srgbClr val="9CA9B5"/>
@@ -6112,7 +6227,7 @@
                   <a:srgbClr val="9CA9B5"/>
                 </a:solidFill>
               </a:rPr>
-              <a:t>Credit rebate + reserve</a:t>
+              <a:t>Hook settles or expires</a:t>
             </a:r>
           </a:p>
         </p:txBody>
@@ -6150,6 +6265,7 @@
           <a:lstStyle xmlns:a="http://schemas.openxmlformats.org/drawingml/2006/main"/>
           <a:p xmlns:a="http://schemas.openxmlformats.org/drawingml/2006/main">
             <a:pPr algn="ctr">
+              <a:buNone/>
               <a:defRPr sz="2100" b="1">
                 <a:solidFill>
                   <a:srgbClr val="8AFFAD"/>
@@ -6229,6 +6345,7 @@
           <a:lstStyle xmlns:a="http://schemas.openxmlformats.org/drawingml/2006/main"/>
           <a:p xmlns:a="http://schemas.openxmlformats.org/drawingml/2006/main">
             <a:pPr>
+              <a:buNone/>
               <a:defRPr sz="1050" b="1">
                 <a:solidFill>
                   <a:srgbClr val="8AFFAD"/>
@@ -6279,6 +6396,7 @@
           <a:lstStyle xmlns:a="http://schemas.openxmlformats.org/drawingml/2006/main"/>
           <a:p xmlns:a="http://schemas.openxmlformats.org/drawingml/2006/main">
             <a:pPr algn="r">
+              <a:buNone/>
               <a:defRPr sz="900">
                 <a:solidFill>
                   <a:srgbClr val="9CA9B5"/>
@@ -6360,6 +6478,7 @@
           <a:lstStyle xmlns:a="http://schemas.openxmlformats.org/drawingml/2006/main"/>
           <a:p xmlns:a="http://schemas.openxmlformats.org/drawingml/2006/main">
             <a:pPr>
+              <a:buNone/>
               <a:defRPr sz="2850" b="1">
                 <a:solidFill>
                   <a:srgbClr val="F4F1E8"/>
@@ -6441,6 +6560,7 @@
           <a:lstStyle xmlns:a="http://schemas.openxmlformats.org/drawingml/2006/main"/>
           <a:p xmlns:a="http://schemas.openxmlformats.org/drawingml/2006/main">
             <a:pPr algn="ctr">
+              <a:buNone/>
               <a:defRPr sz="4800" b="1">
                 <a:solidFill>
                   <a:srgbClr val="F4F1E8"/>
@@ -6453,7 +6573,7 @@
                   <a:srgbClr val="F4F1E8"/>
                 </a:solidFill>
               </a:rPr>
-              <a:t>144</a:t>
+              <a:t>212</a:t>
             </a:r>
           </a:p>
         </p:txBody>
@@ -6491,6 +6611,7 @@
           <a:lstStyle xmlns:a="http://schemas.openxmlformats.org/drawingml/2006/main"/>
           <a:p xmlns:a="http://schemas.openxmlformats.org/drawingml/2006/main">
             <a:pPr algn="ctr">
+              <a:buNone/>
               <a:defRPr sz="1500">
                 <a:solidFill>
                   <a:srgbClr val="9CA9B5"/>
@@ -6508,6 +6629,7 @@
           </a:p>
           <a:p xmlns:a="http://schemas.openxmlformats.org/drawingml/2006/main">
             <a:pPr algn="ctr">
+              <a:buNone/>
               <a:defRPr sz="1500">
                 <a:solidFill>
                   <a:srgbClr val="9CA9B5"/>
@@ -6558,6 +6680,7 @@
           <a:lstStyle xmlns:a="http://schemas.openxmlformats.org/drawingml/2006/main"/>
           <a:p xmlns:a="http://schemas.openxmlformats.org/drawingml/2006/main">
             <a:pPr algn="ctr">
+              <a:buNone/>
               <a:defRPr sz="4800" b="1">
                 <a:solidFill>
                   <a:srgbClr val="F4F1E8"/>
@@ -6608,6 +6731,7 @@
           <a:lstStyle xmlns:a="http://schemas.openxmlformats.org/drawingml/2006/main"/>
           <a:p xmlns:a="http://schemas.openxmlformats.org/drawingml/2006/main">
             <a:pPr algn="ctr">
+              <a:buNone/>
               <a:defRPr sz="1500">
                 <a:solidFill>
                   <a:srgbClr val="9CA9B5"/>
@@ -6625,6 +6749,7 @@
           </a:p>
           <a:p xmlns:a="http://schemas.openxmlformats.org/drawingml/2006/main">
             <a:pPr algn="ctr">
+              <a:buNone/>
               <a:defRPr sz="1500">
                 <a:solidFill>
                   <a:srgbClr val="9CA9B5"/>
@@ -6675,6 +6800,7 @@
           <a:lstStyle xmlns:a="http://schemas.openxmlformats.org/drawingml/2006/main"/>
           <a:p xmlns:a="http://schemas.openxmlformats.org/drawingml/2006/main">
             <a:pPr algn="ctr">
+              <a:buNone/>
               <a:defRPr sz="4800" b="1">
                 <a:solidFill>
                   <a:srgbClr val="8AFFAD"/>
@@ -6725,6 +6851,7 @@
           <a:lstStyle xmlns:a="http://schemas.openxmlformats.org/drawingml/2006/main"/>
           <a:p xmlns:a="http://schemas.openxmlformats.org/drawingml/2006/main">
             <a:pPr algn="ctr">
+              <a:buNone/>
               <a:defRPr sz="1500">
                 <a:solidFill>
                   <a:srgbClr val="9CA9B5"/>
@@ -6742,6 +6869,7 @@
           </a:p>
           <a:p xmlns:a="http://schemas.openxmlformats.org/drawingml/2006/main">
             <a:pPr algn="ctr">
+              <a:buNone/>
               <a:defRPr sz="1500">
                 <a:solidFill>
                   <a:srgbClr val="9CA9B5"/>
@@ -6792,6 +6920,7 @@
           <a:lstStyle xmlns:a="http://schemas.openxmlformats.org/drawingml/2006/main"/>
           <a:p xmlns:a="http://schemas.openxmlformats.org/drawingml/2006/main">
             <a:pPr algn="ctr">
+              <a:buNone/>
               <a:defRPr sz="4800" b="1">
                 <a:solidFill>
                   <a:srgbClr val="F4F1E8"/>
@@ -6842,6 +6971,7 @@
           <a:lstStyle xmlns:a="http://schemas.openxmlformats.org/drawingml/2006/main"/>
           <a:p xmlns:a="http://schemas.openxmlformats.org/drawingml/2006/main">
             <a:pPr algn="ctr">
+              <a:buNone/>
               <a:defRPr sz="1500">
                 <a:solidFill>
                   <a:srgbClr val="9CA9B5"/>
@@ -6859,6 +6989,7 @@
           </a:p>
           <a:p xmlns:a="http://schemas.openxmlformats.org/drawingml/2006/main">
             <a:pPr algn="ctr">
+              <a:buNone/>
               <a:defRPr sz="1500">
                 <a:solidFill>
                   <a:srgbClr val="9CA9B5"/>
@@ -6909,6 +7040,7 @@
           <a:lstStyle xmlns:a="http://schemas.openxmlformats.org/drawingml/2006/main"/>
           <a:p xmlns:a="http://schemas.openxmlformats.org/drawingml/2006/main">
             <a:pPr algn="ctr">
+              <a:buNone/>
               <a:defRPr sz="1575" b="1">
                 <a:solidFill>
                   <a:srgbClr val="8AFFAD"/>
@@ -6988,6 +7120,7 @@
           <a:lstStyle xmlns:a="http://schemas.openxmlformats.org/drawingml/2006/main"/>
           <a:p xmlns:a="http://schemas.openxmlformats.org/drawingml/2006/main">
             <a:pPr>
+              <a:buNone/>
               <a:defRPr sz="1050" b="1">
                 <a:solidFill>
                   <a:srgbClr val="8AFFAD"/>
@@ -7038,6 +7171,7 @@
           <a:lstStyle xmlns:a="http://schemas.openxmlformats.org/drawingml/2006/main"/>
           <a:p xmlns:a="http://schemas.openxmlformats.org/drawingml/2006/main">
             <a:pPr algn="r">
+              <a:buNone/>
               <a:defRPr sz="900">
                 <a:solidFill>
                   <a:srgbClr val="9CA9B5"/>
@@ -7119,6 +7253,7 @@
           <a:lstStyle xmlns:a="http://schemas.openxmlformats.org/drawingml/2006/main"/>
           <a:p xmlns:a="http://schemas.openxmlformats.org/drawingml/2006/main">
             <a:pPr>
+              <a:buNone/>
               <a:defRPr sz="4800" b="1">
                 <a:solidFill>
                   <a:srgbClr val="8AFFAD"/>
@@ -7169,6 +7304,7 @@
           <a:lstStyle xmlns:a="http://schemas.openxmlformats.org/drawingml/2006/main"/>
           <a:p xmlns:a="http://schemas.openxmlformats.org/drawingml/2006/main">
             <a:pPr>
+              <a:buNone/>
               <a:defRPr sz="3000" b="1">
                 <a:solidFill>
                   <a:srgbClr val="F4F1E8"/>
@@ -7250,6 +7386,7 @@
           <a:lstStyle xmlns:a="http://schemas.openxmlformats.org/drawingml/2006/main"/>
           <a:p xmlns:a="http://schemas.openxmlformats.org/drawingml/2006/main">
             <a:pPr>
+              <a:buNone/>
               <a:defRPr sz="1800">
                 <a:solidFill>
                   <a:srgbClr val="9CA9B5"/>
@@ -7267,6 +7404,7 @@
           </a:p>
           <a:p xmlns:a="http://schemas.openxmlformats.org/drawingml/2006/main">
             <a:pPr>
+              <a:buNone/>
               <a:defRPr sz="1800">
                 <a:solidFill>
                   <a:srgbClr val="9CA9B5"/>
@@ -7279,11 +7417,12 @@
                   <a:srgbClr val="9CA9B5"/>
                 </a:solidFill>
               </a:rPr>
-              <a:t>Reactive Network observes, waits, and delivers.</a:t>
+              <a:t>Pyth verifies; Circle carries the primary message.</a:t>
             </a:r>
           </a:p>
           <a:p xmlns:a="http://schemas.openxmlformats.org/drawingml/2006/main">
             <a:pPr>
+              <a:buNone/>
               <a:defRPr sz="1800">
                 <a:solidFill>
                   <a:srgbClr val="9CA9B5"/>
@@ -7296,7 +7435,7 @@
                   <a:srgbClr val="9CA9B5"/>
                 </a:solidFill>
               </a:rPr>
-              <a:t>The outcome decides rebate versus protection.</a:t>
+              <a:t>Reactive may mirror; expiry stays permissionless.</a:t>
             </a:r>
           </a:p>
         </p:txBody>
@@ -7334,6 +7473,7 @@
           <a:lstStyle xmlns:a="http://schemas.openxmlformats.org/drawingml/2006/main"/>
           <a:p xmlns:a="http://schemas.openxmlformats.org/drawingml/2006/main">
             <a:pPr algn="r">
+              <a:buNone/>
               <a:defRPr sz="1650" b="1">
                 <a:solidFill>
                   <a:srgbClr val="8AFFAD"/>
@@ -7346,7 +7486,7 @@
                   <a:srgbClr val="8AFFAD"/>
                 </a:solidFill>
               </a:rPr>
-              <a:t>Final gate: two public autonomous Lasna settlement traces</a:t>
+              <a:t>Final gate: public Circle settlement + claim</a:t>
             </a:r>
           </a:p>
         </p:txBody>

</xml_diff>

<commit_message>
docs: finalize public settlement judge deck
</commit_message>
<xml_diff>
--- a/presentation/MARKOUT-UHI10.pptx
+++ b/presentation/MARKOUT-UHI10.pptx
@@ -2,21 +2,21 @@
 <file path=ppt/presentation.xml><?xml version="1.0" encoding="utf-8"?>
 <p:presentation xmlns:p="http://schemas.openxmlformats.org/presentationml/2006/main">
   <p:sldMasterIdLst>
-    <p:sldMasterId xmlns:r="http://schemas.openxmlformats.org/officeDocument/2006/relationships" id="2147483648" r:id="Rd7fbfe864c8b4a59"/>
+    <p:sldMasterId xmlns:r="http://schemas.openxmlformats.org/officeDocument/2006/relationships" id="2147483648" r:id="Re09a6135306c478f"/>
   </p:sldMasterIdLst>
   <p:notesMasterIdLst>
-    <p:notesMasterId xmlns:r="http://schemas.openxmlformats.org/officeDocument/2006/relationships" r:id="R1501d757e5574688"/>
+    <p:notesMasterId xmlns:r="http://schemas.openxmlformats.org/officeDocument/2006/relationships" r:id="R845b34fa9dab4111"/>
   </p:notesMasterIdLst>
   <p:sldIdLst>
-    <p:sldId xmlns:r="http://schemas.openxmlformats.org/officeDocument/2006/relationships" id="256" r:id="R4a96ce31ccb44d60"/>
-    <p:sldId xmlns:r="http://schemas.openxmlformats.org/officeDocument/2006/relationships" id="257" r:id="R4731a7b6652b47f3"/>
-    <p:sldId xmlns:r="http://schemas.openxmlformats.org/officeDocument/2006/relationships" id="258" r:id="Rcb33d3006756486d"/>
-    <p:sldId xmlns:r="http://schemas.openxmlformats.org/officeDocument/2006/relationships" id="259" r:id="Rcceaf3d34fd541f9"/>
-    <p:sldId xmlns:r="http://schemas.openxmlformats.org/officeDocument/2006/relationships" id="260" r:id="R7b5abfc421eb47af"/>
-    <p:sldId xmlns:r="http://schemas.openxmlformats.org/officeDocument/2006/relationships" id="261" r:id="R03670309ce154302"/>
-    <p:sldId xmlns:r="http://schemas.openxmlformats.org/officeDocument/2006/relationships" id="262" r:id="Ra7fc08a4c1e24cb9"/>
-    <p:sldId xmlns:r="http://schemas.openxmlformats.org/officeDocument/2006/relationships" id="263" r:id="R4039986728c145c2"/>
-    <p:sldId xmlns:r="http://schemas.openxmlformats.org/officeDocument/2006/relationships" id="264" r:id="R61374a8b808643de"/>
+    <p:sldId xmlns:r="http://schemas.openxmlformats.org/officeDocument/2006/relationships" id="256" r:id="Rb8ca0ea7ec8641d8"/>
+    <p:sldId xmlns:r="http://schemas.openxmlformats.org/officeDocument/2006/relationships" id="257" r:id="R06d52f49f6034d0f"/>
+    <p:sldId xmlns:r="http://schemas.openxmlformats.org/officeDocument/2006/relationships" id="258" r:id="Rfafce736516f4de1"/>
+    <p:sldId xmlns:r="http://schemas.openxmlformats.org/officeDocument/2006/relationships" id="259" r:id="Rbd4e5ae6c1654d5e"/>
+    <p:sldId xmlns:r="http://schemas.openxmlformats.org/officeDocument/2006/relationships" id="260" r:id="Rac5437ffdf5845a0"/>
+    <p:sldId xmlns:r="http://schemas.openxmlformats.org/officeDocument/2006/relationships" id="261" r:id="R994ad5a243714ce0"/>
+    <p:sldId xmlns:r="http://schemas.openxmlformats.org/officeDocument/2006/relationships" id="262" r:id="Rb20fedbe002345bf"/>
+    <p:sldId xmlns:r="http://schemas.openxmlformats.org/officeDocument/2006/relationships" id="263" r:id="Rc2ce7644a0de4075"/>
+    <p:sldId xmlns:r="http://schemas.openxmlformats.org/officeDocument/2006/relationships" id="264" r:id="R48b0f2f4d42848d1"/>
   </p:sldIdLst>
   <p:sldSz cx="12192000" cy="6858000"/>
   <p:notesSz cx="6858000" cy="9144000"/>
@@ -1305,17 +1305,27 @@
           <a:lstStyle xmlns:a="http://schemas.openxmlformats.org/drawingml/2006/main"/>
           <a:p xmlns:a="http://schemas.openxmlformats.org/drawingml/2006/main">
             <a:r>
-              <a:t>Resolve the opening: MARKOUT does not need to know intent before execution; it settles what the post-trade outcome supports.</a:t>
-            </a:r>
-          </a:p>
-          <a:p xmlns:a="http://schemas.openxmlformats.org/drawingml/2006/main">
-            <a:r>
-              <a:t>Finish on the real Circle publication, attestation relay, settlement, and rebate claim once those transactions exist.</a:t>
-            </a:r>
-          </a:p>
-          <a:p xmlns:a="http://schemas.openxmlformats.org/drawingml/2006/main">
-            <a:r>
-              <a:t>Show Reactive separately only when a public destination callback exists.</a:t>
+              <a:t>Resolve the opening: MARKOUT does not need to predict intent before execution; it settles what the post-trade outcome supports.</a:t>
+            </a:r>
+          </a:p>
+          <a:p xmlns:a="http://schemas.openxmlformats.org/drawingml/2006/main">
+            <a:r>
+              <a:t>Public proof: the final Ethereum Sepolia publisher block timestamp was 1787307432 and the Unichain settlement block timestamp was 1787307470, a 38-second source-to-destination latency.</a:t>
+            </a:r>
+          </a:p>
+          <a:p xmlns:a="http://schemas.openxmlformats.org/drawingml/2006/main">
+            <a:r>
+              <a:t>The Pyth observation timestamp was 1787307424, so the hook accepted it at 46 seconds of age, within the configured 120-second maximum.</a:t>
+            </a:r>
+          </a:p>
+          <a:p xmlns:a="http://schemas.openxmlformats.org/drawingml/2006/main">
+            <a:r>
+              <a:t>The trade escrowed 622 USDC base units; negative markout allocated 0 to LP protection and all 622 to the trader rebate, which was claimed publicly.</a:t>
+            </a:r>
+          </a:p>
+          <a:p xmlns:a="http://schemas.openxmlformats.org/drawingml/2006/main">
+            <a:r>
+              <a:t>Reactive remains optional: its legacy pulse is deployed and subscribed, but no successful public Unichain callback is claimed.</a:t>
             </a:r>
           </a:p>
           <a:p xmlns:a="http://schemas.openxmlformats.org/drawingml/2006/main">
@@ -1330,12 +1340,32 @@
           </a:p>
           <a:p xmlns:a="http://schemas.openxmlformats.org/drawingml/2006/main">
             <a:r>
-              <a:t>- docs/SUBMISSION_CHECKLIST.md</a:t>
-            </a:r>
-          </a:p>
-          <a:p xmlns:a="http://schemas.openxmlformats.org/drawingml/2006/main">
-            <a:r>
-              <a:t>- docs/HYBRID_TESTNET_DEPLOYMENT.md</a:t>
+              <a:t>- deployments/hybrid-2026-08-21.json</a:t>
+            </a:r>
+          </a:p>
+          <a:p xmlns:a="http://schemas.openxmlformats.org/drawingml/2006/main">
+            <a:r>
+              <a:t>- https://sepolia.etherscan.io/tx/0xed6af5c42e554c221078110d6db03fba8fd74bf24a88cf52494d4e605a31f6ca</a:t>
+            </a:r>
+          </a:p>
+          <a:p xmlns:a="http://schemas.openxmlformats.org/drawingml/2006/main">
+            <a:r>
+              <a:t>- https://sepolia.uniscan.xyz/tx/0xa64789b5a08ea8aae8c2b909b6a81b495334b707eaae12610bf3749902ec532f</a:t>
+            </a:r>
+          </a:p>
+          <a:p xmlns:a="http://schemas.openxmlformats.org/drawingml/2006/main">
+            <a:r>
+              <a:t>- https://sepolia.uniscan.xyz/tx/0xa6ded637a8c9651f252e302f7cedec2969d637f733777f7f2ad71ac700d64630</a:t>
+            </a:r>
+          </a:p>
+          <a:p xmlns:a="http://schemas.openxmlformats.org/drawingml/2006/main">
+            <a:r>
+              <a:t>- https://developers.circle.com/cctp/concepts/finality-and-block-confirmations</a:t>
+            </a:r>
+          </a:p>
+          <a:p xmlns:a="http://schemas.openxmlformats.org/drawingml/2006/main">
+            <a:r>
+              <a:t>- https://docs.pyth.network/price-feeds/core/fetch-price-updates</a:t>
             </a:r>
           </a:p>
           <a:p xmlns:a="http://schemas.openxmlformats.org/drawingml/2006/main">
@@ -1408,7 +1438,7 @@
   </p:cSld>
   <p:clrMap bg1="lt1" tx1="dk1" bg2="lt2" tx2="dk2" accent1="accent1" accent2="accent2" accent3="accent3" accent4="accent4" accent5="accent5" accent6="accent6" hlink="hlink" folHlink="folHlink"/>
   <p:sldLayoutIdLst>
-    <p:sldLayoutId xmlns:r="http://schemas.openxmlformats.org/officeDocument/2006/relationships" id="2147483649" r:id="Rf5788590262047b7"/>
+    <p:sldLayoutId xmlns:r="http://schemas.openxmlformats.org/officeDocument/2006/relationships" id="2147483649" r:id="R6c47b0d0896e4c9d"/>
   </p:sldLayoutIdLst>
   <p:txStyles>
     <p:titleStyle>
@@ -1963,7 +1993,7 @@
           <p:nvPr/>
         </p:nvPicPr>
         <p:blipFill>
-          <a:blip xmlns:r="http://schemas.openxmlformats.org/officeDocument/2006/relationships" xmlns:a="http://schemas.openxmlformats.org/drawingml/2006/main" r:embed="R6d663a9986524bf9"/>
+          <a:blip xmlns:r="http://schemas.openxmlformats.org/officeDocument/2006/relationships" xmlns:a="http://schemas.openxmlformats.org/drawingml/2006/main" r:embed="R5ce7ecbfb5f14080"/>
           <a:stretch xmlns:a="http://schemas.openxmlformats.org/drawingml/2006/main"/>
         </p:blipFill>
         <p:spPr>
@@ -3924,7 +3954,7 @@
       </p:sp>
       <p:cxnSp>
         <p:nvCxnSpPr>
-          <p:cNvPr id="114" name=""/>
+          <p:cNvPr id="172" name=""/>
           <p:cNvCxnSpPr>
             <a:stCxn xmlns:a="http://schemas.openxmlformats.org/drawingml/2006/main" id="6" idx="3"/>
             <a:endCxn xmlns:a="http://schemas.openxmlformats.org/drawingml/2006/main" id="10" idx="1"/>
@@ -3950,7 +3980,7 @@
       </p:cxnSp>
       <p:cxnSp>
         <p:nvCxnSpPr>
-          <p:cNvPr id="115" name=""/>
+          <p:cNvPr id="173" name=""/>
           <p:cNvCxnSpPr>
             <a:stCxn xmlns:a="http://schemas.openxmlformats.org/drawingml/2006/main" id="10" idx="3"/>
             <a:endCxn xmlns:a="http://schemas.openxmlformats.org/drawingml/2006/main" id="14" idx="1"/>
@@ -3976,7 +4006,7 @@
       </p:cxnSp>
       <p:cxnSp>
         <p:nvCxnSpPr>
-          <p:cNvPr id="116" name=""/>
+          <p:cNvPr id="174" name=""/>
           <p:cNvCxnSpPr>
             <a:stCxn xmlns:a="http://schemas.openxmlformats.org/drawingml/2006/main" id="14" idx="3"/>
             <a:endCxn xmlns:a="http://schemas.openxmlformats.org/drawingml/2006/main" id="18" idx="1"/>
@@ -4002,7 +4032,7 @@
       </p:cxnSp>
       <p:cxnSp>
         <p:nvCxnSpPr>
-          <p:cNvPr id="117" name=""/>
+          <p:cNvPr id="175" name=""/>
           <p:cNvCxnSpPr>
             <a:stCxn xmlns:a="http://schemas.openxmlformats.org/drawingml/2006/main" id="18" idx="3"/>
             <a:endCxn xmlns:a="http://schemas.openxmlformats.org/drawingml/2006/main" id="22" idx="1"/>
@@ -4299,7 +4329,7 @@
           <p:nvPr/>
         </p:nvPicPr>
         <p:blipFill>
-          <a:blip xmlns:r="http://schemas.openxmlformats.org/officeDocument/2006/relationships" xmlns:a="http://schemas.openxmlformats.org/drawingml/2006/main" r:embed="R0da935d81a404ec8"/>
+          <a:blip xmlns:r="http://schemas.openxmlformats.org/officeDocument/2006/relationships" xmlns:a="http://schemas.openxmlformats.org/drawingml/2006/main" r:embed="R77536b811ede4991"/>
           <a:stretch xmlns:a="http://schemas.openxmlformats.org/drawingml/2006/main"/>
         </p:blipFill>
         <p:spPr>
@@ -4585,7 +4615,7 @@
           <p:nvPr/>
         </p:nvPicPr>
         <p:blipFill>
-          <a:blip xmlns:r="http://schemas.openxmlformats.org/officeDocument/2006/relationships" xmlns:a="http://schemas.openxmlformats.org/drawingml/2006/main" r:embed="Re6e1980a233246d9"/>
+          <a:blip xmlns:r="http://schemas.openxmlformats.org/officeDocument/2006/relationships" xmlns:a="http://schemas.openxmlformats.org/drawingml/2006/main" r:embed="R771ae37d29fe49f1"/>
           <a:stretch xmlns:a="http://schemas.openxmlformats.org/drawingml/2006/main"/>
         </p:blipFill>
         <p:spPr>
@@ -5060,7 +5090,7 @@
           <p:nvPr/>
         </p:nvPicPr>
         <p:blipFill>
-          <a:blip xmlns:r="http://schemas.openxmlformats.org/officeDocument/2006/relationships" xmlns:a="http://schemas.openxmlformats.org/drawingml/2006/main" r:embed="R5e3b56b4f5294cc7"/>
+          <a:blip xmlns:r="http://schemas.openxmlformats.org/officeDocument/2006/relationships" xmlns:a="http://schemas.openxmlformats.org/drawingml/2006/main" r:embed="R4cdf948bc6b44870"/>
           <a:stretch xmlns:a="http://schemas.openxmlformats.org/drawingml/2006/main"/>
         </p:blipFill>
         <p:spPr>
@@ -5768,7 +5798,7 @@
       </p:sp>
       <p:cxnSp>
         <p:nvCxnSpPr>
-          <p:cNvPr id="46" name=""/>
+          <p:cNvPr id="66" name=""/>
           <p:cNvCxnSpPr>
             <a:stCxn xmlns:a="http://schemas.openxmlformats.org/drawingml/2006/main" id="6" idx="3"/>
             <a:endCxn xmlns:a="http://schemas.openxmlformats.org/drawingml/2006/main" id="7" idx="1"/>
@@ -5794,7 +5824,7 @@
       </p:cxnSp>
       <p:cxnSp>
         <p:nvCxnSpPr>
-          <p:cNvPr id="47" name=""/>
+          <p:cNvPr id="67" name=""/>
           <p:cNvCxnSpPr>
             <a:stCxn xmlns:a="http://schemas.openxmlformats.org/drawingml/2006/main" id="7" idx="3"/>
             <a:endCxn xmlns:a="http://schemas.openxmlformats.org/drawingml/2006/main" id="8" idx="1"/>
@@ -7399,7 +7429,7 @@
                   <a:srgbClr val="9CA9B5"/>
                 </a:solidFill>
               </a:rPr>
-              <a:t>Uniswap v4 holds the provisional value.</a:t>
+              <a:t>Public v4 trade settled through Circle in 38 seconds.</a:t>
             </a:r>
           </a:p>
           <a:p xmlns:a="http://schemas.openxmlformats.org/drawingml/2006/main">
@@ -7417,7 +7447,7 @@
                   <a:srgbClr val="9CA9B5"/>
                 </a:solidFill>
               </a:rPr>
-              <a:t>Pyth verifies; Circle carries the primary message.</a:t>
+              <a:t>Pyth observation arrived with 46 seconds of age.</a:t>
             </a:r>
           </a:p>
           <a:p xmlns:a="http://schemas.openxmlformats.org/drawingml/2006/main">
@@ -7435,7 +7465,7 @@
                   <a:srgbClr val="9CA9B5"/>
                 </a:solidFill>
               </a:rPr>
-              <a:t>Reactive may mirror; expiry stays permissionless.</a:t>
+              <a:t>Negative markout returned 100% of the surcharge.</a:t>
             </a:r>
           </a:p>
         </p:txBody>
@@ -7486,7 +7516,8 @@
                   <a:srgbClr val="8AFFAD"/>
                 </a:solidFill>
               </a:rPr>
-              <a:t>Final gate: public Circle settlement + claim</a:t>
+              <a:t>CIRCLE SETTLED · 38 SEC
+100% REBATED</a:t>
             </a:r>
           </a:p>
         </p:txBody>

</xml_diff>

<commit_message>
docs: add public Circle proof to judge deck
</commit_message>
<xml_diff>
--- a/presentation/MARKOUT-UHI10.pptx
+++ b/presentation/MARKOUT-UHI10.pptx
@@ -2,21 +2,21 @@
 <file path=ppt/presentation.xml><?xml version="1.0" encoding="utf-8"?>
 <p:presentation xmlns:p="http://schemas.openxmlformats.org/presentationml/2006/main">
   <p:sldMasterIdLst>
-    <p:sldMasterId xmlns:r="http://schemas.openxmlformats.org/officeDocument/2006/relationships" id="2147483648" r:id="Re09a6135306c478f"/>
+    <p:sldMasterId xmlns:r="http://schemas.openxmlformats.org/officeDocument/2006/relationships" id="2147483648" r:id="R863b536124a34973"/>
   </p:sldMasterIdLst>
   <p:notesMasterIdLst>
-    <p:notesMasterId xmlns:r="http://schemas.openxmlformats.org/officeDocument/2006/relationships" r:id="R845b34fa9dab4111"/>
+    <p:notesMasterId xmlns:r="http://schemas.openxmlformats.org/officeDocument/2006/relationships" r:id="R8fc93491428b49d9"/>
   </p:notesMasterIdLst>
   <p:sldIdLst>
-    <p:sldId xmlns:r="http://schemas.openxmlformats.org/officeDocument/2006/relationships" id="256" r:id="Rb8ca0ea7ec8641d8"/>
-    <p:sldId xmlns:r="http://schemas.openxmlformats.org/officeDocument/2006/relationships" id="257" r:id="R06d52f49f6034d0f"/>
-    <p:sldId xmlns:r="http://schemas.openxmlformats.org/officeDocument/2006/relationships" id="258" r:id="Rfafce736516f4de1"/>
-    <p:sldId xmlns:r="http://schemas.openxmlformats.org/officeDocument/2006/relationships" id="259" r:id="Rbd4e5ae6c1654d5e"/>
-    <p:sldId xmlns:r="http://schemas.openxmlformats.org/officeDocument/2006/relationships" id="260" r:id="Rac5437ffdf5845a0"/>
-    <p:sldId xmlns:r="http://schemas.openxmlformats.org/officeDocument/2006/relationships" id="261" r:id="R994ad5a243714ce0"/>
-    <p:sldId xmlns:r="http://schemas.openxmlformats.org/officeDocument/2006/relationships" id="262" r:id="Rb20fedbe002345bf"/>
-    <p:sldId xmlns:r="http://schemas.openxmlformats.org/officeDocument/2006/relationships" id="263" r:id="Rc2ce7644a0de4075"/>
-    <p:sldId xmlns:r="http://schemas.openxmlformats.org/officeDocument/2006/relationships" id="264" r:id="R48b0f2f4d42848d1"/>
+    <p:sldId xmlns:r="http://schemas.openxmlformats.org/officeDocument/2006/relationships" id="256" r:id="R7da0b829390d4b62"/>
+    <p:sldId xmlns:r="http://schemas.openxmlformats.org/officeDocument/2006/relationships" id="257" r:id="R32757f94d5674615"/>
+    <p:sldId xmlns:r="http://schemas.openxmlformats.org/officeDocument/2006/relationships" id="258" r:id="R62855139cd7e477b"/>
+    <p:sldId xmlns:r="http://schemas.openxmlformats.org/officeDocument/2006/relationships" id="259" r:id="Re98caebb693448a5"/>
+    <p:sldId xmlns:r="http://schemas.openxmlformats.org/officeDocument/2006/relationships" id="260" r:id="R9f6e608e7ef041b6"/>
+    <p:sldId xmlns:r="http://schemas.openxmlformats.org/officeDocument/2006/relationships" id="261" r:id="R1bdbb950b65b4ebe"/>
+    <p:sldId xmlns:r="http://schemas.openxmlformats.org/officeDocument/2006/relationships" id="262" r:id="Rf9b3480dca14428b"/>
+    <p:sldId xmlns:r="http://schemas.openxmlformats.org/officeDocument/2006/relationships" id="263" r:id="Re379b66f049d4f45"/>
+    <p:sldId xmlns:r="http://schemas.openxmlformats.org/officeDocument/2006/relationships" id="264" r:id="R4552a1e1d5fa4686"/>
   </p:sldIdLst>
   <p:sldSz cx="12192000" cy="6858000"/>
   <p:notesSz cx="6858000" cy="9144000"/>
@@ -1438,7 +1438,7 @@
   </p:cSld>
   <p:clrMap bg1="lt1" tx1="dk1" bg2="lt2" tx2="dk2" accent1="accent1" accent2="accent2" accent3="accent3" accent4="accent4" accent5="accent5" accent6="accent6" hlink="hlink" folHlink="folHlink"/>
   <p:sldLayoutIdLst>
-    <p:sldLayoutId xmlns:r="http://schemas.openxmlformats.org/officeDocument/2006/relationships" id="2147483649" r:id="R6c47b0d0896e4c9d"/>
+    <p:sldLayoutId xmlns:r="http://schemas.openxmlformats.org/officeDocument/2006/relationships" id="2147483649" r:id="Rcff1689a31e442de"/>
   </p:sldLayoutIdLst>
   <p:txStyles>
     <p:titleStyle>
@@ -1993,7 +1993,7 @@
           <p:nvPr/>
         </p:nvPicPr>
         <p:blipFill>
-          <a:blip xmlns:r="http://schemas.openxmlformats.org/officeDocument/2006/relationships" xmlns:a="http://schemas.openxmlformats.org/drawingml/2006/main" r:embed="R5ce7ecbfb5f14080"/>
+          <a:blip xmlns:r="http://schemas.openxmlformats.org/officeDocument/2006/relationships" xmlns:a="http://schemas.openxmlformats.org/drawingml/2006/main" r:embed="R75b8923ce8444e94"/>
           <a:stretch xmlns:a="http://schemas.openxmlformats.org/drawingml/2006/main"/>
         </p:blipFill>
         <p:spPr>
@@ -3954,7 +3954,7 @@
       </p:sp>
       <p:cxnSp>
         <p:nvCxnSpPr>
-          <p:cNvPr id="172" name=""/>
+          <p:cNvPr id="230" name=""/>
           <p:cNvCxnSpPr>
             <a:stCxn xmlns:a="http://schemas.openxmlformats.org/drawingml/2006/main" id="6" idx="3"/>
             <a:endCxn xmlns:a="http://schemas.openxmlformats.org/drawingml/2006/main" id="10" idx="1"/>
@@ -3980,7 +3980,7 @@
       </p:cxnSp>
       <p:cxnSp>
         <p:nvCxnSpPr>
-          <p:cNvPr id="173" name=""/>
+          <p:cNvPr id="231" name=""/>
           <p:cNvCxnSpPr>
             <a:stCxn xmlns:a="http://schemas.openxmlformats.org/drawingml/2006/main" id="10" idx="3"/>
             <a:endCxn xmlns:a="http://schemas.openxmlformats.org/drawingml/2006/main" id="14" idx="1"/>
@@ -4006,7 +4006,7 @@
       </p:cxnSp>
       <p:cxnSp>
         <p:nvCxnSpPr>
-          <p:cNvPr id="174" name=""/>
+          <p:cNvPr id="232" name=""/>
           <p:cNvCxnSpPr>
             <a:stCxn xmlns:a="http://schemas.openxmlformats.org/drawingml/2006/main" id="14" idx="3"/>
             <a:endCxn xmlns:a="http://schemas.openxmlformats.org/drawingml/2006/main" id="18" idx="1"/>
@@ -4032,7 +4032,7 @@
       </p:cxnSp>
       <p:cxnSp>
         <p:nvCxnSpPr>
-          <p:cNvPr id="175" name=""/>
+          <p:cNvPr id="233" name=""/>
           <p:cNvCxnSpPr>
             <a:stCxn xmlns:a="http://schemas.openxmlformats.org/drawingml/2006/main" id="18" idx="3"/>
             <a:endCxn xmlns:a="http://schemas.openxmlformats.org/drawingml/2006/main" id="22" idx="1"/>
@@ -4329,7 +4329,7 @@
           <p:nvPr/>
         </p:nvPicPr>
         <p:blipFill>
-          <a:blip xmlns:r="http://schemas.openxmlformats.org/officeDocument/2006/relationships" xmlns:a="http://schemas.openxmlformats.org/drawingml/2006/main" r:embed="R77536b811ede4991"/>
+          <a:blip xmlns:r="http://schemas.openxmlformats.org/officeDocument/2006/relationships" xmlns:a="http://schemas.openxmlformats.org/drawingml/2006/main" r:embed="Rc1e3ce76d71c4eea"/>
           <a:stretch xmlns:a="http://schemas.openxmlformats.org/drawingml/2006/main"/>
         </p:blipFill>
         <p:spPr>
@@ -4615,7 +4615,7 @@
           <p:nvPr/>
         </p:nvPicPr>
         <p:blipFill>
-          <a:blip xmlns:r="http://schemas.openxmlformats.org/officeDocument/2006/relationships" xmlns:a="http://schemas.openxmlformats.org/drawingml/2006/main" r:embed="R771ae37d29fe49f1"/>
+          <a:blip xmlns:r="http://schemas.openxmlformats.org/officeDocument/2006/relationships" xmlns:a="http://schemas.openxmlformats.org/drawingml/2006/main" r:embed="R4dae6ca4e6dc4655"/>
           <a:stretch xmlns:a="http://schemas.openxmlformats.org/drawingml/2006/main"/>
         </p:blipFill>
         <p:spPr>
@@ -5090,7 +5090,7 @@
           <p:nvPr/>
         </p:nvPicPr>
         <p:blipFill>
-          <a:blip xmlns:r="http://schemas.openxmlformats.org/officeDocument/2006/relationships" xmlns:a="http://schemas.openxmlformats.org/drawingml/2006/main" r:embed="R4cdf948bc6b44870"/>
+          <a:blip xmlns:r="http://schemas.openxmlformats.org/officeDocument/2006/relationships" xmlns:a="http://schemas.openxmlformats.org/drawingml/2006/main" r:embed="R5199a60674b84d59"/>
           <a:stretch xmlns:a="http://schemas.openxmlformats.org/drawingml/2006/main"/>
         </p:blipFill>
         <p:spPr>
@@ -5798,7 +5798,7 @@
       </p:sp>
       <p:cxnSp>
         <p:nvCxnSpPr>
-          <p:cNvPr id="66" name=""/>
+          <p:cNvPr id="86" name=""/>
           <p:cNvCxnSpPr>
             <a:stCxn xmlns:a="http://schemas.openxmlformats.org/drawingml/2006/main" id="6" idx="3"/>
             <a:endCxn xmlns:a="http://schemas.openxmlformats.org/drawingml/2006/main" id="7" idx="1"/>
@@ -5824,7 +5824,7 @@
       </p:cxnSp>
       <p:cxnSp>
         <p:nvCxnSpPr>
-          <p:cNvPr id="67" name=""/>
+          <p:cNvPr id="87" name=""/>
           <p:cNvCxnSpPr>
             <a:stCxn xmlns:a="http://schemas.openxmlformats.org/drawingml/2006/main" id="7" idx="3"/>
             <a:endCxn xmlns:a="http://schemas.openxmlformats.org/drawingml/2006/main" id="8" idx="1"/>
@@ -6603,7 +6603,7 @@
                   <a:srgbClr val="F4F1E8"/>
                 </a:solidFill>
               </a:rPr>
-              <a:t>212</a:t>
+              <a:t>186</a:t>
             </a:r>
           </a:p>
         </p:txBody>

</xml_diff>

<commit_message>
docs: finalize dual-outcome judge deck
</commit_message>
<xml_diff>
--- a/presentation/MARKOUT-UHI10.pptx
+++ b/presentation/MARKOUT-UHI10.pptx
@@ -2,21 +2,21 @@
 <file path=ppt/presentation.xml><?xml version="1.0" encoding="utf-8"?>
 <p:presentation xmlns:p="http://schemas.openxmlformats.org/presentationml/2006/main">
   <p:sldMasterIdLst>
-    <p:sldMasterId xmlns:r="http://schemas.openxmlformats.org/officeDocument/2006/relationships" id="2147483648" r:id="R863b536124a34973"/>
+    <p:sldMasterId xmlns:r="http://schemas.openxmlformats.org/officeDocument/2006/relationships" id="2147483648" r:id="R08f3f3cf56a344de"/>
   </p:sldMasterIdLst>
   <p:notesMasterIdLst>
-    <p:notesMasterId xmlns:r="http://schemas.openxmlformats.org/officeDocument/2006/relationships" r:id="R8fc93491428b49d9"/>
+    <p:notesMasterId xmlns:r="http://schemas.openxmlformats.org/officeDocument/2006/relationships" r:id="Ra07b6c4e509647df"/>
   </p:notesMasterIdLst>
   <p:sldIdLst>
-    <p:sldId xmlns:r="http://schemas.openxmlformats.org/officeDocument/2006/relationships" id="256" r:id="R7da0b829390d4b62"/>
-    <p:sldId xmlns:r="http://schemas.openxmlformats.org/officeDocument/2006/relationships" id="257" r:id="R32757f94d5674615"/>
-    <p:sldId xmlns:r="http://schemas.openxmlformats.org/officeDocument/2006/relationships" id="258" r:id="R62855139cd7e477b"/>
-    <p:sldId xmlns:r="http://schemas.openxmlformats.org/officeDocument/2006/relationships" id="259" r:id="Re98caebb693448a5"/>
-    <p:sldId xmlns:r="http://schemas.openxmlformats.org/officeDocument/2006/relationships" id="260" r:id="R9f6e608e7ef041b6"/>
-    <p:sldId xmlns:r="http://schemas.openxmlformats.org/officeDocument/2006/relationships" id="261" r:id="R1bdbb950b65b4ebe"/>
-    <p:sldId xmlns:r="http://schemas.openxmlformats.org/officeDocument/2006/relationships" id="262" r:id="Rf9b3480dca14428b"/>
-    <p:sldId xmlns:r="http://schemas.openxmlformats.org/officeDocument/2006/relationships" id="263" r:id="Re379b66f049d4f45"/>
-    <p:sldId xmlns:r="http://schemas.openxmlformats.org/officeDocument/2006/relationships" id="264" r:id="R4552a1e1d5fa4686"/>
+    <p:sldId xmlns:r="http://schemas.openxmlformats.org/officeDocument/2006/relationships" id="256" r:id="R4fc829dfb33d4f1b"/>
+    <p:sldId xmlns:r="http://schemas.openxmlformats.org/officeDocument/2006/relationships" id="257" r:id="Rf91080a5afd84d1d"/>
+    <p:sldId xmlns:r="http://schemas.openxmlformats.org/officeDocument/2006/relationships" id="258" r:id="R9b22f8d40b394ed8"/>
+    <p:sldId xmlns:r="http://schemas.openxmlformats.org/officeDocument/2006/relationships" id="259" r:id="R807f5ad9ab974e9e"/>
+    <p:sldId xmlns:r="http://schemas.openxmlformats.org/officeDocument/2006/relationships" id="260" r:id="Rc2dac76d7b0a4495"/>
+    <p:sldId xmlns:r="http://schemas.openxmlformats.org/officeDocument/2006/relationships" id="261" r:id="R6a4ef8f55ddc470e"/>
+    <p:sldId xmlns:r="http://schemas.openxmlformats.org/officeDocument/2006/relationships" id="262" r:id="R7ab5cc48031746e4"/>
+    <p:sldId xmlns:r="http://schemas.openxmlformats.org/officeDocument/2006/relationships" id="263" r:id="R9ab775430ad747a3"/>
+    <p:sldId xmlns:r="http://schemas.openxmlformats.org/officeDocument/2006/relationships" id="264" r:id="Rb71f98fe46ea438b"/>
   </p:sldIdLst>
   <p:sldSz cx="12192000" cy="6858000"/>
   <p:notesSz cx="6858000" cy="9144000"/>
@@ -1310,17 +1310,17 @@
           </a:p>
           <a:p xmlns:a="http://schemas.openxmlformats.org/drawingml/2006/main">
             <a:r>
-              <a:t>Public proof: the final Ethereum Sepolia publisher block timestamp was 1787307432 and the Unichain settlement block timestamp was 1787307470, a 38-second source-to-destination latency.</a:t>
-            </a:r>
-          </a:p>
-          <a:p xmlns:a="http://schemas.openxmlformats.org/drawingml/2006/main">
-            <a:r>
-              <a:t>The Pyth observation timestamp was 1787307424, so the hook accepted it at 46 seconds of age, within the configured 120-second maximum.</a:t>
-            </a:r>
-          </a:p>
-          <a:p xmlns:a="http://schemas.openxmlformats.org/drawingml/2006/main">
-            <a:r>
-              <a:t>The trade escrowed 622 USDC base units; negative markout allocated 0 to LP protection and all 622 to the trader rebate, which was claimed publicly.</a:t>
+              <a:t>Negative-markout proof: a 38-second Circle relay delivered a 46-second-old Pyth observation, allocated 0 to LP protection, and returned all 622 test-USDC base units to the trader; the rebate was claimed publicly.</a:t>
+            </a:r>
+          </a:p>
+          <a:p xmlns:a="http://schemas.openxmlformats.org/drawingml/2006/main">
+            <a:r>
+              <a:t>Positive-markout proof: a 67-second Circle relay delivered a 96-second-old Pyth observation and retained all 3,214,110,616,342 test-WETH base units for LP protection.</a:t>
+            </a:r>
+          </a:p>
+          <a:p xmlns:a="http://schemas.openxmlformats.org/drawingml/2006/main">
+            <a:r>
+              <a:t>The second trade's LP-protection reserve, accounted balance, and actual token balance are equal onchain.</a:t>
             </a:r>
           </a:p>
           <a:p xmlns:a="http://schemas.openxmlformats.org/drawingml/2006/main">
@@ -1360,12 +1360,17 @@
           </a:p>
           <a:p xmlns:a="http://schemas.openxmlformats.org/drawingml/2006/main">
             <a:r>
-              <a:t>- https://developers.circle.com/cctp/concepts/finality-and-block-confirmations</a:t>
-            </a:r>
-          </a:p>
-          <a:p xmlns:a="http://schemas.openxmlformats.org/drawingml/2006/main">
-            <a:r>
-              <a:t>- https://docs.pyth.network/price-feeds/core/fetch-price-updates</a:t>
+              <a:t>- https://sepolia.uniscan.xyz/tx/0xb6179eab5dcf9ff2f3563442dbf826fe5fcb86524e9d71aa913c9ba9e90a2376</a:t>
+            </a:r>
+          </a:p>
+          <a:p xmlns:a="http://schemas.openxmlformats.org/drawingml/2006/main">
+            <a:r>
+              <a:t>- https://sepolia.etherscan.io/tx/0x9d20a2a8bfc5c7dd654608a9214472ff3ed37cbdff4614064aff28805f9f8861</a:t>
+            </a:r>
+          </a:p>
+          <a:p xmlns:a="http://schemas.openxmlformats.org/drawingml/2006/main">
+            <a:r>
+              <a:t>- https://sepolia.uniscan.xyz/tx/0xefeece5de9f78ae809652418e1fcd8fb592de950af64e6bbbf66df93bdc25eae</a:t>
             </a:r>
           </a:p>
           <a:p xmlns:a="http://schemas.openxmlformats.org/drawingml/2006/main">
@@ -1438,7 +1443,7 @@
   </p:cSld>
   <p:clrMap bg1="lt1" tx1="dk1" bg2="lt2" tx2="dk2" accent1="accent1" accent2="accent2" accent3="accent3" accent4="accent4" accent5="accent5" accent6="accent6" hlink="hlink" folHlink="folHlink"/>
   <p:sldLayoutIdLst>
-    <p:sldLayoutId xmlns:r="http://schemas.openxmlformats.org/officeDocument/2006/relationships" id="2147483649" r:id="Rcff1689a31e442de"/>
+    <p:sldLayoutId xmlns:r="http://schemas.openxmlformats.org/officeDocument/2006/relationships" id="2147483649" r:id="R24b51edecc334b8e"/>
   </p:sldLayoutIdLst>
   <p:txStyles>
     <p:titleStyle>
@@ -1993,7 +1998,7 @@
           <p:nvPr/>
         </p:nvPicPr>
         <p:blipFill>
-          <a:blip xmlns:r="http://schemas.openxmlformats.org/officeDocument/2006/relationships" xmlns:a="http://schemas.openxmlformats.org/drawingml/2006/main" r:embed="R75b8923ce8444e94"/>
+          <a:blip xmlns:r="http://schemas.openxmlformats.org/officeDocument/2006/relationships" xmlns:a="http://schemas.openxmlformats.org/drawingml/2006/main" r:embed="R025924c93c97427e"/>
           <a:stretch xmlns:a="http://schemas.openxmlformats.org/drawingml/2006/main"/>
         </p:blipFill>
         <p:spPr>
@@ -3954,7 +3959,7 @@
       </p:sp>
       <p:cxnSp>
         <p:nvCxnSpPr>
-          <p:cNvPr id="230" name=""/>
+          <p:cNvPr id="288" name=""/>
           <p:cNvCxnSpPr>
             <a:stCxn xmlns:a="http://schemas.openxmlformats.org/drawingml/2006/main" id="6" idx="3"/>
             <a:endCxn xmlns:a="http://schemas.openxmlformats.org/drawingml/2006/main" id="10" idx="1"/>
@@ -3980,7 +3985,7 @@
       </p:cxnSp>
       <p:cxnSp>
         <p:nvCxnSpPr>
-          <p:cNvPr id="231" name=""/>
+          <p:cNvPr id="289" name=""/>
           <p:cNvCxnSpPr>
             <a:stCxn xmlns:a="http://schemas.openxmlformats.org/drawingml/2006/main" id="10" idx="3"/>
             <a:endCxn xmlns:a="http://schemas.openxmlformats.org/drawingml/2006/main" id="14" idx="1"/>
@@ -4006,7 +4011,7 @@
       </p:cxnSp>
       <p:cxnSp>
         <p:nvCxnSpPr>
-          <p:cNvPr id="232" name=""/>
+          <p:cNvPr id="290" name=""/>
           <p:cNvCxnSpPr>
             <a:stCxn xmlns:a="http://schemas.openxmlformats.org/drawingml/2006/main" id="14" idx="3"/>
             <a:endCxn xmlns:a="http://schemas.openxmlformats.org/drawingml/2006/main" id="18" idx="1"/>
@@ -4032,7 +4037,7 @@
       </p:cxnSp>
       <p:cxnSp>
         <p:nvCxnSpPr>
-          <p:cNvPr id="233" name=""/>
+          <p:cNvPr id="291" name=""/>
           <p:cNvCxnSpPr>
             <a:stCxn xmlns:a="http://schemas.openxmlformats.org/drawingml/2006/main" id="18" idx="3"/>
             <a:endCxn xmlns:a="http://schemas.openxmlformats.org/drawingml/2006/main" id="22" idx="1"/>
@@ -4329,7 +4334,7 @@
           <p:nvPr/>
         </p:nvPicPr>
         <p:blipFill>
-          <a:blip xmlns:r="http://schemas.openxmlformats.org/officeDocument/2006/relationships" xmlns:a="http://schemas.openxmlformats.org/drawingml/2006/main" r:embed="Rc1e3ce76d71c4eea"/>
+          <a:blip xmlns:r="http://schemas.openxmlformats.org/officeDocument/2006/relationships" xmlns:a="http://schemas.openxmlformats.org/drawingml/2006/main" r:embed="R0b4f9c8b0cac4e19"/>
           <a:stretch xmlns:a="http://schemas.openxmlformats.org/drawingml/2006/main"/>
         </p:blipFill>
         <p:spPr>
@@ -4615,7 +4620,7 @@
           <p:nvPr/>
         </p:nvPicPr>
         <p:blipFill>
-          <a:blip xmlns:r="http://schemas.openxmlformats.org/officeDocument/2006/relationships" xmlns:a="http://schemas.openxmlformats.org/drawingml/2006/main" r:embed="R4dae6ca4e6dc4655"/>
+          <a:blip xmlns:r="http://schemas.openxmlformats.org/officeDocument/2006/relationships" xmlns:a="http://schemas.openxmlformats.org/drawingml/2006/main" r:embed="Rbcdb2eeb7f5248c5"/>
           <a:stretch xmlns:a="http://schemas.openxmlformats.org/drawingml/2006/main"/>
         </p:blipFill>
         <p:spPr>
@@ -5090,7 +5095,7 @@
           <p:nvPr/>
         </p:nvPicPr>
         <p:blipFill>
-          <a:blip xmlns:r="http://schemas.openxmlformats.org/officeDocument/2006/relationships" xmlns:a="http://schemas.openxmlformats.org/drawingml/2006/main" r:embed="R5199a60674b84d59"/>
+          <a:blip xmlns:r="http://schemas.openxmlformats.org/officeDocument/2006/relationships" xmlns:a="http://schemas.openxmlformats.org/drawingml/2006/main" r:embed="Rf2881d82627540eb"/>
           <a:stretch xmlns:a="http://schemas.openxmlformats.org/drawingml/2006/main"/>
         </p:blipFill>
         <p:spPr>
@@ -5798,7 +5803,7 @@
       </p:sp>
       <p:cxnSp>
         <p:nvCxnSpPr>
-          <p:cNvPr id="86" name=""/>
+          <p:cNvPr id="106" name=""/>
           <p:cNvCxnSpPr>
             <a:stCxn xmlns:a="http://schemas.openxmlformats.org/drawingml/2006/main" id="6" idx="3"/>
             <a:endCxn xmlns:a="http://schemas.openxmlformats.org/drawingml/2006/main" id="7" idx="1"/>
@@ -5824,7 +5829,7 @@
       </p:cxnSp>
       <p:cxnSp>
         <p:nvCxnSpPr>
-          <p:cNvPr id="87" name=""/>
+          <p:cNvPr id="107" name=""/>
           <p:cNvCxnSpPr>
             <a:stCxn xmlns:a="http://schemas.openxmlformats.org/drawingml/2006/main" id="7" idx="3"/>
             <a:endCxn xmlns:a="http://schemas.openxmlformats.org/drawingml/2006/main" id="8" idx="1"/>
@@ -7429,7 +7434,7 @@
                   <a:srgbClr val="9CA9B5"/>
                 </a:solidFill>
               </a:rPr>
-              <a:t>Public v4 trade settled through Circle in 38 seconds.</a:t>
+              <a:t>Negative markout settled in 38s → 100% rebated.</a:t>
             </a:r>
           </a:p>
           <a:p xmlns:a="http://schemas.openxmlformats.org/drawingml/2006/main">
@@ -7447,7 +7452,7 @@
                   <a:srgbClr val="9CA9B5"/>
                 </a:solidFill>
               </a:rPr>
-              <a:t>Pyth observation arrived with 46 seconds of age.</a:t>
+              <a:t>Positive markout settled in 67s → 100% retained.</a:t>
             </a:r>
           </a:p>
           <a:p xmlns:a="http://schemas.openxmlformats.org/drawingml/2006/main">
@@ -7465,7 +7470,7 @@
                   <a:srgbClr val="9CA9B5"/>
                 </a:solidFill>
               </a:rPr>
-              <a:t>Negative markout returned 100% of the surcharge.</a:t>
+              <a:t>Two public v4 trades prove both allocation extremes.</a:t>
             </a:r>
           </a:p>
         </p:txBody>
@@ -7516,8 +7521,8 @@
                   <a:srgbClr val="8AFFAD"/>
                 </a:solidFill>
               </a:rPr>
-              <a:t>CIRCLE SETTLED · 38 SEC
-100% REBATED</a:t>
+              <a:t>100% REBATED
+100% RETAINED</a:t>
             </a:r>
           </a:p>
         </p:txBody>

</xml_diff>